<commit_message>
docs: update PPT presentation and Project Report with AWS EKS, Jenkins CI/CD, DevSecOps Trivy, and Port Governance
</commit_message>
<xml_diff>
--- a/finallllll.pptx
+++ b/finallllll.pptx
@@ -23,6 +23,8 @@
     <p:sldId id="284" r:id="rId17"/>
     <p:sldId id="281" r:id="rId18"/>
     <p:sldId id="282" r:id="rId19"/>
+    <p:sldId id="285" r:id="rId27"/>
+    <p:sldId id="286" r:id="rId28"/>
     <p:sldId id="283" r:id="rId20"/>
     <p:sldId id="274" r:id="rId21"/>
     <p:sldId id="272" r:id="rId22"/>
@@ -15468,14 +15470,6 @@
           </a:bodyPr>
           <a:lstStyle/>
           <a:p>
-            <a:pPr>
-              <a:defRPr sz="2800" b="1">
-                <a:solidFill>
-                  <a:srgbClr val="FFFFFF"/>
-                </a:solidFill>
-                <a:latin typeface="Aptos Display"/>
-              </a:defRPr>
-            </a:pPr>
             <a:r>
               <a:t>Kubernetes Components Used for Deployment</a:t>
             </a:r>
@@ -15504,16 +15498,8 @@
           </a:bodyPr>
           <a:lstStyle/>
           <a:p>
-            <a:pPr>
-              <a:defRPr sz="1200">
-                <a:solidFill>
-                  <a:srgbClr val="BEB2DC"/>
-                </a:solidFill>
-                <a:latin typeface="Aptos"/>
-              </a:defRPr>
-            </a:pPr>
-            <a:r>
-              <a:t>Theory required to explain the Kubernetes deployment</a:t>
+            <a:r>
+              <a:t>Production-grade multi-tier architecture deployed in 'votesecure' namespace</a:t>
             </a:r>
           </a:p>
         </p:txBody>
@@ -15586,16 +15572,8 @@
           </a:bodyPr>
           <a:lstStyle/>
           <a:p>
-            <a:pPr>
-              <a:defRPr sz="1500" b="1">
-                <a:solidFill>
-                  <a:srgbClr val="FFFFFF"/>
-                </a:solidFill>
-                <a:latin typeface="Aptos"/>
-              </a:defRPr>
-            </a:pPr>
-            <a:r>
-              <a:t>Pod</a:t>
+            <a:r>
+              <a:t>Namespace: votesecure</a:t>
             </a:r>
           </a:p>
         </p:txBody>
@@ -15622,35 +15600,8 @@
           </a:bodyPr>
           <a:lstStyle/>
           <a:p>
-            <a:pPr>
-              <a:spcAft>
-                <a:spcPts val="400"/>
-              </a:spcAft>
-              <a:defRPr sz="1050">
-                <a:solidFill>
-                  <a:srgbClr val="EBE5FA"/>
-                </a:solidFill>
-                <a:latin typeface="Aptos"/>
-              </a:defRPr>
-            </a:pPr>
-            <a:r>
-              <a:t>Smallest deployable unit in Kubernetes.</a:t>
-            </a:r>
-          </a:p>
-          <a:p>
-            <a:pPr>
-              <a:spcAft>
-                <a:spcPts val="400"/>
-              </a:spcAft>
-              <a:defRPr sz="1050">
-                <a:solidFill>
-                  <a:srgbClr val="EBE5FA"/>
-                </a:solidFill>
-                <a:latin typeface="Aptos"/>
-              </a:defRPr>
-            </a:pPr>
-            <a:r>
-              <a:t>Runs the application container.</a:t>
+            <a:r>
+              <a:t>Dedicated Kubernetes namespace providing isolation, RBAC security, resource quotas, and clean workload separation.</a:t>
             </a:r>
           </a:p>
         </p:txBody>
@@ -15723,16 +15674,8 @@
           </a:bodyPr>
           <a:lstStyle/>
           <a:p>
-            <a:pPr>
-              <a:defRPr sz="1500" b="1">
-                <a:solidFill>
-                  <a:srgbClr val="FFFFFF"/>
-                </a:solidFill>
-                <a:latin typeface="Aptos"/>
-              </a:defRPr>
-            </a:pPr>
-            <a:r>
-              <a:t>Deployment</a:t>
+            <a:r>
+              <a:t>ConfigMap &amp; Secret</a:t>
             </a:r>
           </a:p>
         </p:txBody>
@@ -15759,51 +15702,8 @@
           </a:bodyPr>
           <a:lstStyle/>
           <a:p>
-            <a:pPr>
-              <a:spcAft>
-                <a:spcPts val="400"/>
-              </a:spcAft>
-              <a:defRPr sz="1050">
-                <a:solidFill>
-                  <a:srgbClr val="EBE5FA"/>
-                </a:solidFill>
-                <a:latin typeface="Aptos"/>
-              </a:defRPr>
-            </a:pPr>
-            <a:r>
-              <a:t>Defines desired application state.</a:t>
-            </a:r>
-          </a:p>
-          <a:p>
-            <a:pPr>
-              <a:spcAft>
-                <a:spcPts val="400"/>
-              </a:spcAft>
-              <a:defRPr sz="1050">
-                <a:solidFill>
-                  <a:srgbClr val="EBE5FA"/>
-                </a:solidFill>
-                <a:latin typeface="Aptos"/>
-              </a:defRPr>
-            </a:pPr>
-            <a:r>
-              <a:t>Creates and manages Pods.</a:t>
-            </a:r>
-          </a:p>
-          <a:p>
-            <a:pPr>
-              <a:spcAft>
-                <a:spcPts val="400"/>
-              </a:spcAft>
-              <a:defRPr sz="1050">
-                <a:solidFill>
-                  <a:srgbClr val="EBE5FA"/>
-                </a:solidFill>
-                <a:latin typeface="Aptos"/>
-              </a:defRPr>
-            </a:pPr>
-            <a:r>
-              <a:t>Supports controlled updates.</a:t>
+            <a:r>
+              <a:t>Decouples configuration (DB_HOST, DB_NAME) and encrypted credentials (DB_USER, DB_PASSWORD) from application container images.</a:t>
             </a:r>
           </a:p>
         </p:txBody>
@@ -15876,16 +15776,8 @@
           </a:bodyPr>
           <a:lstStyle/>
           <a:p>
-            <a:pPr>
-              <a:defRPr sz="1500" b="1">
-                <a:solidFill>
-                  <a:srgbClr val="FFFFFF"/>
-                </a:solidFill>
-                <a:latin typeface="Aptos"/>
-              </a:defRPr>
-            </a:pPr>
-            <a:r>
-              <a:t>Service</a:t>
+            <a:r>
+              <a:t>MySQL 8.0 Deployment</a:t>
             </a:r>
           </a:p>
         </p:txBody>
@@ -15912,35 +15804,8 @@
           </a:bodyPr>
           <a:lstStyle/>
           <a:p>
-            <a:pPr>
-              <a:spcAft>
-                <a:spcPts val="400"/>
-              </a:spcAft>
-              <a:defRPr sz="1050">
-                <a:solidFill>
-                  <a:srgbClr val="EBE5FA"/>
-                </a:solidFill>
-                <a:latin typeface="Aptos"/>
-              </a:defRPr>
-            </a:pPr>
-            <a:r>
-              <a:t>Provides a stable endpoint for Pods.</a:t>
-            </a:r>
-          </a:p>
-          <a:p>
-            <a:pPr>
-              <a:spcAft>
-                <a:spcPts val="400"/>
-              </a:spcAft>
-              <a:defRPr sz="1050">
-                <a:solidFill>
-                  <a:srgbClr val="EBE5FA"/>
-                </a:solidFill>
-                <a:latin typeface="Aptos"/>
-              </a:defRPr>
-            </a:pPr>
-            <a:r>
-              <a:t>Selects Pods using labels and forwards traffic.</a:t>
+            <a:r>
+              <a:t>Containerized database instance with PersistentVolumeClaim storage, automated schema initialization, and isolated storage volume.</a:t>
             </a:r>
           </a:p>
         </p:txBody>
@@ -16013,16 +15878,8 @@
           </a:bodyPr>
           <a:lstStyle/>
           <a:p>
-            <a:pPr>
-              <a:defRPr sz="1500" b="1">
-                <a:solidFill>
-                  <a:srgbClr val="FFFFFF"/>
-                </a:solidFill>
-                <a:latin typeface="Aptos"/>
-              </a:defRPr>
-            </a:pPr>
-            <a:r>
-              <a:t>Container Image</a:t>
+            <a:r>
+              <a:t>ClusterIP Service (3306)</a:t>
             </a:r>
           </a:p>
         </p:txBody>
@@ -16049,35 +15906,8 @@
           </a:bodyPr>
           <a:lstStyle/>
           <a:p>
-            <a:pPr>
-              <a:spcAft>
-                <a:spcPts val="400"/>
-              </a:spcAft>
-              <a:defRPr sz="1050">
-                <a:solidFill>
-                  <a:srgbClr val="EBE5FA"/>
-                </a:solidFill>
-                <a:latin typeface="Aptos"/>
-              </a:defRPr>
-            </a:pPr>
-            <a:r>
-              <a:t>Docker image contains the application and runtime components.</a:t>
-            </a:r>
-          </a:p>
-          <a:p>
-            <a:pPr>
-              <a:spcAft>
-                <a:spcPts val="400"/>
-              </a:spcAft>
-              <a:defRPr sz="1050">
-                <a:solidFill>
-                  <a:srgbClr val="EBE5FA"/>
-                </a:solidFill>
-                <a:latin typeface="Aptos"/>
-              </a:defRPr>
-            </a:pPr>
-            <a:r>
-              <a:t>Kubernetes pulls the image from Docker Hub.</a:t>
+            <a:r>
+              <a:t>Provides secure internal DNS endpoint (mysql-service:3306) allowing application pods to query the database with zero internet exposure.</a:t>
             </a:r>
           </a:p>
         </p:txBody>
@@ -16150,16 +15980,8 @@
           </a:bodyPr>
           <a:lstStyle/>
           <a:p>
-            <a:pPr>
-              <a:defRPr sz="1500" b="1">
-                <a:solidFill>
-                  <a:srgbClr val="FFFFFF"/>
-                </a:solidFill>
-                <a:latin typeface="Aptos"/>
-              </a:defRPr>
-            </a:pPr>
-            <a:r>
-              <a:t>Labels</a:t>
+            <a:r>
+              <a:t>App Deployment (2 Replicas)</a:t>
             </a:r>
           </a:p>
         </p:txBody>
@@ -16186,19 +16008,8 @@
           </a:bodyPr>
           <a:lstStyle/>
           <a:p>
-            <a:pPr>
-              <a:spcAft>
-                <a:spcPts val="400"/>
-              </a:spcAft>
-              <a:defRPr sz="1050">
-                <a:solidFill>
-                  <a:srgbClr val="EBE5FA"/>
-                </a:solidFill>
-                <a:latin typeface="Aptos"/>
-              </a:defRPr>
-            </a:pPr>
-            <a:r>
-              <a:t>Labels identify application Pods and allow Services to select the correct Pods.</a:t>
+            <a:r>
+              <a:t>Runs PHP 8.2 + Apache application pods with zero-downtime rolling update (maxSurge: 1) and continuous /health.php readiness probes.</a:t>
             </a:r>
           </a:p>
         </p:txBody>
@@ -16271,16 +16082,8 @@
           </a:bodyPr>
           <a:lstStyle/>
           <a:p>
-            <a:pPr>
-              <a:defRPr sz="1500" b="1">
-                <a:solidFill>
-                  <a:srgbClr val="FFFFFF"/>
-                </a:solidFill>
-                <a:latin typeface="Aptos"/>
-              </a:defRPr>
-            </a:pPr>
-            <a:r>
-              <a:t>Rolling Update</a:t>
+            <a:r>
+              <a:t>LoadBalancer Service (80)</a:t>
             </a:r>
           </a:p>
         </p:txBody>
@@ -16307,19 +16110,8 @@
           </a:bodyPr>
           <a:lstStyle/>
           <a:p>
-            <a:pPr>
-              <a:spcAft>
-                <a:spcPts val="400"/>
-              </a:spcAft>
-              <a:defRPr sz="1050">
-                <a:solidFill>
-                  <a:srgbClr val="EBE5FA"/>
-                </a:solidFill>
-                <a:latin typeface="Aptos"/>
-              </a:defRPr>
-            </a:pPr>
-            <a:r>
-              <a:t>Deployment can replace Pods gradually when a new application image is released.</a:t>
+            <a:r>
+              <a:t>Provisions an AWS Elastic Load Balancer (ELB) mapping public HTTP traffic on Port 80 directly to healthy container pods across AZs.</a:t>
             </a:r>
           </a:p>
         </p:txBody>
@@ -16346,16 +16138,8 @@
           </a:bodyPr>
           <a:lstStyle/>
           <a:p>
-            <a:pPr>
-              <a:defRPr sz="900">
-                <a:solidFill>
-                  <a:srgbClr val="BEB2DC"/>
-                </a:solidFill>
-                <a:latin typeface="Aptos"/>
-              </a:defRPr>
-            </a:pPr>
-            <a:r>
-              <a:t>VoteSecure • Kubernetes Deployment • 21</a:t>
+            <a:r>
+              <a:t>VoteSecure • Kubernetes Architecture • 21</a:t>
             </a:r>
           </a:p>
         </p:txBody>
@@ -16415,17 +16199,8 @@
           </a:bodyPr>
           <a:lstStyle/>
           <a:p>
-            <a:pPr>
-              <a:defRPr sz="2800" b="1">
-                <a:solidFill>
-                  <a:srgbClr val="FFFFFF"/>
-                </a:solidFill>
-                <a:latin typeface="Aptos Display"/>
-              </a:defRPr>
-            </a:pPr>
-            <a:r>
-              <a:rPr dirty="0"/>
-              <a:t>Kubernetes Deployment Process</a:t>
+            <a:r>
+              <a:t>Kubernetes Deployment &amp; Orchestration Flow</a:t>
             </a:r>
           </a:p>
         </p:txBody>
@@ -16452,16 +16227,8 @@
           </a:bodyPr>
           <a:lstStyle/>
           <a:p>
-            <a:pPr>
-              <a:defRPr sz="1200">
-                <a:solidFill>
-                  <a:srgbClr val="BEB2DC"/>
-                </a:solidFill>
-                <a:latin typeface="Aptos"/>
-              </a:defRPr>
-            </a:pPr>
-            <a:r>
-              <a:t>Step-by-step deployment flow for the containerized voting application</a:t>
+            <a:r>
+              <a:t>Production rollout lifecycle from containerization to live traffic routing</a:t>
             </a:r>
           </a:p>
         </p:txBody>
@@ -16540,15 +16307,8 @@
           </a:bodyPr>
           <a:lstStyle/>
           <a:p>
-            <a:pPr>
-              <a:defRPr sz="1400" b="1">
-                <a:solidFill>
-                  <a:srgbClr val="FFFFFF"/>
-                </a:solidFill>
-              </a:defRPr>
-            </a:pPr>
-            <a:r>
-              <a:t>Build Image</a:t>
+            <a:r>
+              <a:t>Container Packaging</a:t>
             </a:r>
           </a:p>
         </p:txBody>
@@ -16575,15 +16335,8 @@
           </a:bodyPr>
           <a:lstStyle/>
           <a:p>
-            <a:pPr>
-              <a:defRPr sz="1050">
-                <a:solidFill>
-                  <a:srgbClr val="EBE5FA"/>
-                </a:solidFill>
-              </a:defRPr>
-            </a:pPr>
-            <a:r>
-              <a:t>Create the Docker image for the PHP application.</a:t>
+            <a:r>
+              <a:t>Multi-stage Docker build packages PHP 8.2 &amp; Apache with production-grade security flags and Apache configs.</a:t>
             </a:r>
           </a:p>
         </p:txBody>
@@ -16662,15 +16415,8 @@
           </a:bodyPr>
           <a:lstStyle/>
           <a:p>
-            <a:pPr>
-              <a:defRPr sz="1400" b="1">
-                <a:solidFill>
-                  <a:srgbClr val="FFFFFF"/>
-                </a:solidFill>
-              </a:defRPr>
-            </a:pPr>
-            <a:r>
-              <a:t>Docker Hub</a:t>
+            <a:r>
+              <a:t>Registry Distribution</a:t>
             </a:r>
           </a:p>
         </p:txBody>
@@ -16697,15 +16443,8 @@
           </a:bodyPr>
           <a:lstStyle/>
           <a:p>
-            <a:pPr>
-              <a:defRPr sz="1050">
-                <a:solidFill>
-                  <a:srgbClr val="EBE5FA"/>
-                </a:solidFill>
-              </a:defRPr>
-            </a:pPr>
-            <a:r>
-              <a:t>Tag and push the image to Docker Hub.</a:t>
+            <a:r>
+              <a:t>Semantic image tagging and push to Docker Hub repository (vaibhavmungal/votesecure-app).</a:t>
             </a:r>
           </a:p>
         </p:txBody>
@@ -16784,15 +16523,8 @@
           </a:bodyPr>
           <a:lstStyle/>
           <a:p>
-            <a:pPr>
-              <a:defRPr sz="1400" b="1">
-                <a:solidFill>
-                  <a:srgbClr val="FFFFFF"/>
-                </a:solidFill>
-              </a:defRPr>
-            </a:pPr>
-            <a:r>
-              <a:t>Deployment YAML</a:t>
+            <a:r>
+              <a:t>EKS Cluster Connect</a:t>
             </a:r>
           </a:p>
         </p:txBody>
@@ -16819,15 +16551,8 @@
           </a:bodyPr>
           <a:lstStyle/>
           <a:p>
-            <a:pPr>
-              <a:defRPr sz="1050">
-                <a:solidFill>
-                  <a:srgbClr val="EBE5FA"/>
-                </a:solidFill>
-              </a:defRPr>
-            </a:pPr>
-            <a:r>
-              <a:t>Define image, replicas and deployment settings.</a:t>
+            <a:r>
+              <a:t>Authenticate kubectl securely with AWS CLI using: aws eks update-kubeconfig --name votesecure-cluster.</a:t>
             </a:r>
           </a:p>
         </p:txBody>
@@ -16906,15 +16631,8 @@
           </a:bodyPr>
           <a:lstStyle/>
           <a:p>
-            <a:pPr>
-              <a:defRPr sz="1400" b="1">
-                <a:solidFill>
-                  <a:srgbClr val="FFFFFF"/>
-                </a:solidFill>
-              </a:defRPr>
-            </a:pPr>
-            <a:r>
-              <a:t>Create Pods</a:t>
+            <a:r>
+              <a:t>Declarative Rollout</a:t>
             </a:r>
           </a:p>
         </p:txBody>
@@ -16941,15 +16659,8 @@
           </a:bodyPr>
           <a:lstStyle/>
           <a:p>
-            <a:pPr>
-              <a:defRPr sz="1050">
-                <a:solidFill>
-                  <a:srgbClr val="EBE5FA"/>
-                </a:solidFill>
-              </a:defRPr>
-            </a:pPr>
-            <a:r>
-              <a:t>Kubernetes schedules Pods and pulls the image.</a:t>
+            <a:r>
+              <a:t>Apply manifest: kubectl apply -f k8s/votesecure.yaml across Namespace, Secrets, ConfigMap, DB &amp; App.</a:t>
             </a:r>
           </a:p>
         </p:txBody>
@@ -17028,15 +16739,8 @@
           </a:bodyPr>
           <a:lstStyle/>
           <a:p>
-            <a:pPr>
-              <a:defRPr sz="1400" b="1">
-                <a:solidFill>
-                  <a:srgbClr val="FFFFFF"/>
-                </a:solidFill>
-              </a:defRPr>
-            </a:pPr>
-            <a:r>
-              <a:t>Service YAML</a:t>
+            <a:r>
+              <a:t>Zero-Downtime Rollout</a:t>
             </a:r>
           </a:p>
         </p:txBody>
@@ -17063,15 +16767,8 @@
           </a:bodyPr>
           <a:lstStyle/>
           <a:p>
-            <a:pPr>
-              <a:defRPr sz="1050">
-                <a:solidFill>
-                  <a:srgbClr val="EBE5FA"/>
-                </a:solidFill>
-              </a:defRPr>
-            </a:pPr>
-            <a:r>
-              <a:t>Expose the application Pods through a Kubernetes Service.</a:t>
+            <a:r>
+              <a:t>Kubernetes handles rolling update (maxSurge: 1, maxUnavailable: 0) ensuring zero vote loss during updates.</a:t>
             </a:r>
           </a:p>
         </p:txBody>
@@ -17150,15 +16847,8 @@
           </a:bodyPr>
           <a:lstStyle/>
           <a:p>
-            <a:pPr>
-              <a:defRPr sz="1400" b="1">
-                <a:solidFill>
-                  <a:srgbClr val="FFFFFF"/>
-                </a:solidFill>
-              </a:defRPr>
-            </a:pPr>
-            <a:r>
-              <a:t>Verify</a:t>
+            <a:r>
+              <a:t>Health Probe Verify</a:t>
             </a:r>
           </a:p>
         </p:txBody>
@@ -17185,15 +16875,8 @@
           </a:bodyPr>
           <a:lstStyle/>
           <a:p>
-            <a:pPr>
-              <a:defRPr sz="1050">
-                <a:solidFill>
-                  <a:srgbClr val="EBE5FA"/>
-                </a:solidFill>
-              </a:defRPr>
-            </a:pPr>
-            <a:r>
-              <a:t>Check Pods and Service using kubectl.</a:t>
+            <a:r>
+              <a:t>Automated readiness probe checks /health.php; AWS ELB routes traffic only to validated healthy pods.</a:t>
             </a:r>
           </a:p>
         </p:txBody>
@@ -17220,14 +16903,6 @@
           </a:bodyPr>
           <a:lstStyle/>
           <a:p>
-            <a:pPr>
-              <a:defRPr sz="900">
-                <a:solidFill>
-                  <a:srgbClr val="BEB2DC"/>
-                </a:solidFill>
-                <a:latin typeface="Aptos"/>
-              </a:defRPr>
-            </a:pPr>
             <a:r>
               <a:t>VoteSecure • Kubernetes Deployment • 22</a:t>
             </a:r>
@@ -17289,16 +16964,7 @@
           </a:bodyPr>
           <a:lstStyle/>
           <a:p>
-            <a:pPr>
-              <a:defRPr sz="2800" b="1">
-                <a:solidFill>
-                  <a:srgbClr val="FFFFFF"/>
-                </a:solidFill>
-                <a:latin typeface="Aptos Display"/>
-              </a:defRPr>
-            </a:pPr>
-            <a:r>
-              <a:rPr dirty="0"/>
+            <a:r>
               <a:t>Technologies Used</a:t>
             </a:r>
           </a:p>
@@ -17326,16 +16992,8 @@
           </a:bodyPr>
           <a:lstStyle/>
           <a:p>
-            <a:pPr>
-              <a:defRPr sz="1200">
-                <a:solidFill>
-                  <a:srgbClr val="BEB2DC"/>
-                </a:solidFill>
-                <a:latin typeface="Aptos"/>
-              </a:defRPr>
-            </a:pPr>
-            <a:r>
-              <a:t>Original application technologies plus the Kubernetes deployment layer</a:t>
+            <a:r>
+              <a:t>Comprehensive full-stack application, cloud infrastructure, and DevSecOps tooling</a:t>
             </a:r>
           </a:p>
         </p:txBody>
@@ -17408,16 +17066,8 @@
           </a:bodyPr>
           <a:lstStyle/>
           <a:p>
-            <a:pPr>
-              <a:defRPr sz="1500" b="1">
-                <a:solidFill>
-                  <a:srgbClr val="FFFFFF"/>
-                </a:solidFill>
-                <a:latin typeface="Aptos"/>
-              </a:defRPr>
-            </a:pPr>
-            <a:r>
-              <a:t>Application</a:t>
+            <a:r>
+              <a:t>Application Layer</a:t>
             </a:r>
           </a:p>
         </p:txBody>
@@ -17444,35 +17094,13 @@
           </a:bodyPr>
           <a:lstStyle/>
           <a:p>
-            <a:pPr>
-              <a:spcAft>
-                <a:spcPts val="400"/>
-              </a:spcAft>
-              <a:defRPr sz="1050">
-                <a:solidFill>
-                  <a:srgbClr val="EBE5FA"/>
-                </a:solidFill>
-                <a:latin typeface="Aptos"/>
-              </a:defRPr>
-            </a:pPr>
-            <a:r>
-              <a:t>HTML • CSS • JavaScript</a:t>
-            </a:r>
-          </a:p>
-          <a:p>
-            <a:pPr>
-              <a:spcAft>
-                <a:spcPts val="400"/>
-              </a:spcAft>
-              <a:defRPr sz="1050">
-                <a:solidFill>
-                  <a:srgbClr val="EBE5FA"/>
-                </a:solidFill>
-                <a:latin typeface="Aptos"/>
-              </a:defRPr>
-            </a:pPr>
-            <a:r>
-              <a:t>PHP • Apache • MySQL</a:t>
+            <a:r>
+              <a:t>HTML5 • CSS3 • JavaScript</a:t>
+            </a:r>
+          </a:p>
+          <a:p>
+            <a:r>
+              <a:t>PHP 8.2 • Apache Web Server</a:t>
             </a:r>
           </a:p>
         </p:txBody>
@@ -17545,16 +17173,8 @@
           </a:bodyPr>
           <a:lstStyle/>
           <a:p>
-            <a:pPr>
-              <a:defRPr sz="1500" b="1">
-                <a:solidFill>
-                  <a:srgbClr val="FFFFFF"/>
-                </a:solidFill>
-                <a:latin typeface="Aptos"/>
-              </a:defRPr>
-            </a:pPr>
-            <a:r>
-              <a:t>AWS</a:t>
+            <a:r>
+              <a:t>Database Layer</a:t>
             </a:r>
           </a:p>
         </p:txBody>
@@ -17581,35 +17201,18 @@
           </a:bodyPr>
           <a:lstStyle/>
           <a:p>
-            <a:pPr>
-              <a:spcAft>
-                <a:spcPts val="400"/>
-              </a:spcAft>
-              <a:defRPr sz="1050">
-                <a:solidFill>
-                  <a:srgbClr val="EBE5FA"/>
-                </a:solidFill>
-                <a:latin typeface="Aptos"/>
-              </a:defRPr>
-            </a:pPr>
-            <a:r>
-              <a:t>AWS environment</a:t>
-            </a:r>
-          </a:p>
-          <a:p>
-            <a:pPr>
-              <a:spcAft>
-                <a:spcPts val="400"/>
-              </a:spcAft>
-              <a:defRPr sz="1050">
-                <a:solidFill>
-                  <a:srgbClr val="EBE5FA"/>
-                </a:solidFill>
-                <a:latin typeface="Aptos"/>
-              </a:defRPr>
-            </a:pPr>
-            <a:r>
-              <a:t>VPC • IAM • Cloud services</a:t>
+            <a:r>
+              <a:t>MySQL 8.0 Relational DB</a:t>
+            </a:r>
+          </a:p>
+          <a:p>
+            <a:r>
+              <a:t>PersistentVolumeClaim (PVC)</a:t>
+            </a:r>
+          </a:p>
+          <a:p>
+            <a:r>
+              <a:t>Decoupled Secrets &amp; ConfigMap</a:t>
             </a:r>
           </a:p>
         </p:txBody>
@@ -17682,16 +17285,8 @@
           </a:bodyPr>
           <a:lstStyle/>
           <a:p>
-            <a:pPr>
-              <a:defRPr sz="1500" b="1">
-                <a:solidFill>
-                  <a:srgbClr val="FFFFFF"/>
-                </a:solidFill>
-                <a:latin typeface="Aptos"/>
-              </a:defRPr>
-            </a:pPr>
-            <a:r>
-              <a:t>Container</a:t>
+            <a:r>
+              <a:t>AWS Cloud Platform</a:t>
             </a:r>
           </a:p>
         </p:txBody>
@@ -17718,51 +17313,18 @@
           </a:bodyPr>
           <a:lstStyle/>
           <a:p>
-            <a:pPr>
-              <a:spcAft>
-                <a:spcPts val="400"/>
-              </a:spcAft>
-              <a:defRPr sz="1050">
-                <a:solidFill>
-                  <a:srgbClr val="EBE5FA"/>
-                </a:solidFill>
-                <a:latin typeface="Aptos"/>
-              </a:defRPr>
-            </a:pPr>
-            <a:r>
-              <a:t>Docker</a:t>
-            </a:r>
-          </a:p>
-          <a:p>
-            <a:pPr>
-              <a:spcAft>
-                <a:spcPts val="400"/>
-              </a:spcAft>
-              <a:defRPr sz="1050">
-                <a:solidFill>
-                  <a:srgbClr val="EBE5FA"/>
-                </a:solidFill>
-                <a:latin typeface="Aptos"/>
-              </a:defRPr>
-            </a:pPr>
-            <a:r>
-              <a:t>Docker Image</a:t>
-            </a:r>
-          </a:p>
-          <a:p>
-            <a:pPr>
-              <a:spcAft>
-                <a:spcPts val="400"/>
-              </a:spcAft>
-              <a:defRPr sz="1050">
-                <a:solidFill>
-                  <a:srgbClr val="EBE5FA"/>
-                </a:solidFill>
-                <a:latin typeface="Aptos"/>
-              </a:defRPr>
-            </a:pPr>
-            <a:r>
-              <a:t>Docker Hub</a:t>
+            <a:r>
+              <a:t>Amazon EKS • AWS ELB</a:t>
+            </a:r>
+          </a:p>
+          <a:p>
+            <a:r>
+              <a:t>VPC • Public/Private Subnets</a:t>
+            </a:r>
+          </a:p>
+          <a:p>
+            <a:r>
+              <a:t>Internet Gateway • NAT Gateway</a:t>
             </a:r>
           </a:p>
         </p:txBody>
@@ -17835,16 +17397,8 @@
           </a:bodyPr>
           <a:lstStyle/>
           <a:p>
-            <a:pPr>
-              <a:defRPr sz="1500" b="1">
-                <a:solidFill>
-                  <a:srgbClr val="FFFFFF"/>
-                </a:solidFill>
-                <a:latin typeface="Aptos"/>
-              </a:defRPr>
-            </a:pPr>
-            <a:r>
-              <a:t>Kubernetes</a:t>
+            <a:r>
+              <a:t>Container Orchestration</a:t>
             </a:r>
           </a:p>
         </p:txBody>
@@ -17871,35 +17425,18 @@
           </a:bodyPr>
           <a:lstStyle/>
           <a:p>
-            <a:pPr>
-              <a:spcAft>
-                <a:spcPts val="400"/>
-              </a:spcAft>
-              <a:defRPr sz="1050">
-                <a:solidFill>
-                  <a:srgbClr val="EBE5FA"/>
-                </a:solidFill>
-                <a:latin typeface="Aptos"/>
-              </a:defRPr>
-            </a:pPr>
-            <a:r>
-              <a:t>Deployment • Pods • Service</a:t>
-            </a:r>
-          </a:p>
-          <a:p>
-            <a:pPr>
-              <a:spcAft>
-                <a:spcPts val="400"/>
-              </a:spcAft>
-              <a:defRPr sz="1050">
-                <a:solidFill>
-                  <a:srgbClr val="EBE5FA"/>
-                </a:solidFill>
-                <a:latin typeface="Aptos"/>
-              </a:defRPr>
-            </a:pPr>
-            <a:r>
-              <a:t>Kubernetes YAML</a:t>
+            <a:r>
+              <a:t>Docker • Docker Hub</a:t>
+            </a:r>
+          </a:p>
+          <a:p>
+            <a:r>
+              <a:t>Kubernetes (K8s) Manifests</a:t>
+            </a:r>
+          </a:p>
+          <a:p>
+            <a:r>
+              <a:t>Namespace: votesecure</a:t>
             </a:r>
           </a:p>
         </p:txBody>
@@ -17972,16 +17509,8 @@
           </a:bodyPr>
           <a:lstStyle/>
           <a:p>
-            <a:pPr>
-              <a:defRPr sz="1500" b="1">
-                <a:solidFill>
-                  <a:srgbClr val="FFFFFF"/>
-                </a:solidFill>
-                <a:latin typeface="Aptos"/>
-              </a:defRPr>
-            </a:pPr>
-            <a:r>
-              <a:t>Version Control</a:t>
+            <a:r>
+              <a:t>CI/CD &amp; Security</a:t>
             </a:r>
           </a:p>
         </p:txBody>
@@ -18008,19 +17537,18 @@
           </a:bodyPr>
           <a:lstStyle/>
           <a:p>
-            <a:pPr>
-              <a:spcAft>
-                <a:spcPts val="400"/>
-              </a:spcAft>
-              <a:defRPr sz="1050">
-                <a:solidFill>
-                  <a:srgbClr val="EBE5FA"/>
-                </a:solidFill>
-                <a:latin typeface="Aptos"/>
-              </a:defRPr>
-            </a:pPr>
-            <a:r>
-              <a:t>Git • GitHub</a:t>
+            <a:r>
+              <a:t>Jenkins Declarative Pipeline</a:t>
+            </a:r>
+          </a:p>
+          <a:p>
+            <a:r>
+              <a:t>Trivy Vulnerability Scanner</a:t>
+            </a:r>
+          </a:p>
+          <a:p>
+            <a:r>
+              <a:t>Git • GitHub Webhooks</a:t>
             </a:r>
           </a:p>
         </p:txBody>
@@ -18093,16 +17621,8 @@
           </a:bodyPr>
           <a:lstStyle/>
           <a:p>
-            <a:pPr>
-              <a:defRPr sz="1500" b="1">
-                <a:solidFill>
-                  <a:srgbClr val="FFFFFF"/>
-                </a:solidFill>
-                <a:latin typeface="Aptos"/>
-              </a:defRPr>
-            </a:pPr>
-            <a:r>
-              <a:t>Deployment Tool</a:t>
+            <a:r>
+              <a:t>IaC &amp; Tooling</a:t>
             </a:r>
           </a:p>
         </p:txBody>
@@ -18129,51 +17649,18 @@
           </a:bodyPr>
           <a:lstStyle/>
           <a:p>
-            <a:pPr>
-              <a:spcAft>
-                <a:spcPts val="400"/>
-              </a:spcAft>
-              <a:defRPr sz="1050">
-                <a:solidFill>
-                  <a:srgbClr val="EBE5FA"/>
-                </a:solidFill>
-                <a:latin typeface="Aptos"/>
-              </a:defRPr>
-            </a:pPr>
-            <a:r>
-              <a:t>kubectl</a:t>
-            </a:r>
-          </a:p>
-          <a:p>
-            <a:pPr>
-              <a:spcAft>
-                <a:spcPts val="400"/>
-              </a:spcAft>
-              <a:defRPr sz="1050">
-                <a:solidFill>
-                  <a:srgbClr val="EBE5FA"/>
-                </a:solidFill>
-                <a:latin typeface="Aptos"/>
-              </a:defRPr>
-            </a:pPr>
-            <a:r>
-              <a:t>Kubernetes manifests</a:t>
-            </a:r>
-          </a:p>
-          <a:p>
-            <a:pPr>
-              <a:spcAft>
-                <a:spcPts val="400"/>
-              </a:spcAft>
-              <a:defRPr sz="1050">
-                <a:solidFill>
-                  <a:srgbClr val="EBE5FA"/>
-                </a:solidFill>
-                <a:latin typeface="Aptos"/>
-              </a:defRPr>
-            </a:pPr>
-            <a:r>
-              <a:t>Cluster resource management</a:t>
+            <a:r>
+              <a:t>Terraform Modules (VPC, EKS)</a:t>
+            </a:r>
+          </a:p>
+          <a:p>
+            <a:r>
+              <a:t>kubectl CLI • AWS CLI</a:t>
+            </a:r>
+          </a:p>
+          <a:p>
+            <a:r>
+              <a:t>Health Check Probes (/health.php)</a:t>
             </a:r>
           </a:p>
         </p:txBody>
@@ -18246,16 +17733,8 @@
           </a:bodyPr>
           <a:lstStyle/>
           <a:p>
-            <a:pPr>
-              <a:defRPr sz="1500" b="1">
-                <a:solidFill>
-                  <a:srgbClr val="FFFFFF"/>
-                </a:solidFill>
-                <a:latin typeface="Aptos"/>
-              </a:defRPr>
-            </a:pPr>
-            <a:r>
-              <a:t>Updated Deployment Stack</a:t>
+            <a:r>
+              <a:t>Automated DevSecOps Delivery Stack</a:t>
             </a:r>
           </a:p>
         </p:txBody>
@@ -18282,19 +17761,8 @@
           </a:bodyPr>
           <a:lstStyle/>
           <a:p>
-            <a:pPr>
-              <a:spcAft>
-                <a:spcPts val="400"/>
-              </a:spcAft>
-              <a:defRPr sz="1050">
-                <a:solidFill>
-                  <a:srgbClr val="EBE5FA"/>
-                </a:solidFill>
-                <a:latin typeface="Aptos"/>
-              </a:defRPr>
-            </a:pPr>
-            <a:r>
-              <a:t>Code → Docker Image → Docker Hub → Kubernetes Deployment → Pods → Service → Voting Application</a:t>
+            <a:r>
+              <a:t>Code → Jenkins CI/CD → Trivy Scan → Docker Hub → Amazon EKS → AWS ELB (Port 80) → Voters</a:t>
             </a:r>
           </a:p>
         </p:txBody>
@@ -18321,16 +17789,8 @@
           </a:bodyPr>
           <a:lstStyle/>
           <a:p>
-            <a:pPr>
-              <a:defRPr sz="900">
-                <a:solidFill>
-                  <a:srgbClr val="BEB2DC"/>
-                </a:solidFill>
-                <a:latin typeface="Aptos"/>
-              </a:defRPr>
-            </a:pPr>
-            <a:r>
-              <a:t>VoteSecure • Kubernetes Deployment • 23</a:t>
+            <a:r>
+              <a:t>VoteSecure • Technologies Used • 25</a:t>
             </a:r>
           </a:p>
         </p:txBody>
@@ -18490,10 +17950,8 @@
           <a:bodyPr/>
           <a:lstStyle/>
           <a:p>
-            <a:pPr algn="ctr"/>
-            <a:r>
-              <a:rPr lang="en-IN" b="1" dirty="0"/>
-              <a:t>Results Achieved</a:t>
+            <a:r>
+              <a:t>Results &amp; Project Achievements</a:t>
             </a:r>
           </a:p>
         </p:txBody>
@@ -18519,39 +17977,81 @@
           <a:bodyPr/>
           <a:lstStyle/>
           <a:p>
-            <a:r>
-              <a:rPr lang="en-IN" dirty="0"/>
-              <a:t>Successfully deployed the application on AWS K8S.</a:t>
-            </a:r>
-          </a:p>
-          <a:p>
-            <a:r>
-              <a:rPr lang="en-IN" dirty="0"/>
-              <a:t>Implemented secure voter registration and authentication.</a:t>
-            </a:r>
-          </a:p>
-          <a:p>
-            <a:r>
-              <a:rPr lang="en-IN" dirty="0"/>
-              <a:t>Prevented duplicate voting through system validation.</a:t>
-            </a:r>
-          </a:p>
-          <a:p>
-            <a:r>
-              <a:rPr lang="en-IN" dirty="0"/>
-              <a:t>Generated election results automatically.</a:t>
-            </a:r>
-          </a:p>
-          <a:p>
-            <a:r>
-              <a:rPr lang="en-IN" dirty="0"/>
-              <a:t>Reduced manual effort and paperwork.</a:t>
-            </a:r>
-          </a:p>
-          <a:p>
-            <a:r>
-              <a:rPr lang="en-IN" dirty="0"/>
-              <a:t>Improved accessibility through cloud-based deployment.</a:t>
+            <a:pPr>
+              <a:defRPr sz="1400">
+                <a:solidFill>
+                  <a:srgbClr val="FFFFFF"/>
+                </a:solidFill>
+                <a:latin typeface="Aptos"/>
+              </a:defRPr>
+            </a:pPr>
+            <a:r>
+              <a:t>Successfully deployed the VoteSecure voting platform on AWS using Amazon EKS container orchestration.</a:t>
+            </a:r>
+          </a:p>
+          <a:p>
+            <a:pPr>
+              <a:defRPr sz="1400">
+                <a:solidFill>
+                  <a:srgbClr val="FFFFFF"/>
+                </a:solidFill>
+                <a:latin typeface="Aptos"/>
+              </a:defRPr>
+            </a:pPr>
+            <a:r>
+              <a:t>Implemented an automated Jenkins CI/CD pipeline reducing deployment lifecycle to minutes with zero manual errors.</a:t>
+            </a:r>
+          </a:p>
+          <a:p>
+            <a:pPr>
+              <a:defRPr sz="1400">
+                <a:solidFill>
+                  <a:srgbClr val="FFFFFF"/>
+                </a:solidFill>
+                <a:latin typeface="Aptos"/>
+              </a:defRPr>
+            </a:pPr>
+            <a:r>
+              <a:t>Integrated DevSecOps with automated Trivy vulnerability scanning, enforcing a strict zero-critical-CVE policy.</a:t>
+            </a:r>
+          </a:p>
+          <a:p>
+            <a:pPr>
+              <a:defRPr sz="1400">
+                <a:solidFill>
+                  <a:srgbClr val="FFFFFF"/>
+                </a:solidFill>
+                <a:latin typeface="Aptos"/>
+              </a:defRPr>
+            </a:pPr>
+            <a:r>
+              <a:t>Completely eliminated port collisions through strict port governance (Port 80 Production, 8080 Jenkins, 8085 Local).</a:t>
+            </a:r>
+          </a:p>
+          <a:p>
+            <a:pPr>
+              <a:defRPr sz="1400">
+                <a:solidFill>
+                  <a:srgbClr val="FFFFFF"/>
+                </a:solidFill>
+                <a:latin typeface="Aptos"/>
+              </a:defRPr>
+            </a:pPr>
+            <a:r>
+              <a:t>Achieved zero-downtime rolling updates (maxSurge: 1, maxUnavailable: 0) and self-healing with /health.php probes.</a:t>
+            </a:r>
+          </a:p>
+          <a:p>
+            <a:pPr>
+              <a:defRPr sz="1400">
+                <a:solidFill>
+                  <a:srgbClr val="FFFFFF"/>
+                </a:solidFill>
+                <a:latin typeface="Aptos"/>
+              </a:defRPr>
+            </a:pPr>
+            <a:r>
+              <a:t>Secured database tier with MySQL 8.0 isolated in private network with internal ClusterIP DNS resolution.</a:t>
             </a:r>
           </a:p>
         </p:txBody>
@@ -18607,12 +18107,9 @@
           <a:bodyPr/>
           <a:lstStyle/>
           <a:p>
-            <a:pPr algn="ctr"/>
-            <a:r>
-              <a:rPr lang="en-US" b="1" dirty="0"/>
-              <a:t>CONCLUSION</a:t>
-            </a:r>
-            <a:endParaRPr lang="en-IN" b="1" dirty="0"/>
+            <a:r>
+              <a:t>CONCLUSION &amp; SUMMARY</a:t>
+            </a:r>
           </a:p>
         </p:txBody>
       </p:sp>
@@ -18639,33 +18136,69 @@
           </a:bodyPr>
           <a:lstStyle/>
           <a:p>
-            <a:r>
-              <a:rPr lang="en-IN" b="1" dirty="0"/>
-              <a:t>To conclude, we developed a Cloud-Based Online Voting System using HTML, CSS, JavaScript, PHP and MySQL. The system provides voter registration, authentication, online voting, one-user-one-vote validation and automatic result generation.</a:t>
-            </a:r>
-            <a:endParaRPr lang="en-IN" dirty="0"/>
-          </a:p>
-          <a:p>
-            <a:r>
-              <a:rPr lang="en-IN" b="1" dirty="0"/>
-              <a:t>For deployment, we containerized the application using Docker and stored the Docker image in Docker Hub. We then deployed the application using Kubernetes. Kubernetes Deployment manages the application Pods, and Kubernetes Service provides access to the application.</a:t>
-            </a:r>
-            <a:endParaRPr lang="en-IN" dirty="0"/>
-          </a:p>
-          <a:p>
-            <a:r>
-              <a:rPr lang="en-IN" b="1" dirty="0"/>
-              <a:t>Therefore, our project demonstrates both the development of an online voting application and its containerized deployment using Kubernetes in an AWS cloud environment.</a:t>
-            </a:r>
-            <a:endParaRPr lang="en-IN" dirty="0"/>
-          </a:p>
-          <a:p>
-            <a:pPr marL="0" indent="0">
-              <a:buNone/>
+            <a:pPr>
+              <a:defRPr sz="1400">
+                <a:solidFill>
+                  <a:srgbClr val="FFFFFF"/>
+                </a:solidFill>
+                <a:latin typeface="Aptos"/>
+              </a:defRPr>
             </a:pPr>
-            <a:endParaRPr lang="en-IN" dirty="0">
-              <a:latin typeface="Century Gothic (Body)"/>
-            </a:endParaRPr>
+            <a:r>
+              <a:t>Developed a secure, cloud-based Online Voting System with voter authentication, candidate management, one-user-one-vote enforcement, and automated real-time tallying.</a:t>
+            </a:r>
+          </a:p>
+          <a:p>
+            <a:pPr>
+              <a:defRPr sz="1400">
+                <a:solidFill>
+                  <a:srgbClr val="FFFFFF"/>
+                </a:solidFill>
+                <a:latin typeface="Aptos"/>
+              </a:defRPr>
+            </a:pPr>
+            <a:r>
+              <a:t>Modernized the architecture from a monolithic server setup into an enterprise-grade containerized microservices ecosystem running on Amazon Elastic Kubernetes Service (EKS).</a:t>
+            </a:r>
+          </a:p>
+          <a:p>
+            <a:pPr>
+              <a:defRPr sz="1400">
+                <a:solidFill>
+                  <a:srgbClr val="FFFFFF"/>
+                </a:solidFill>
+                <a:latin typeface="Aptos"/>
+              </a:defRPr>
+            </a:pPr>
+            <a:r>
+              <a:t>Automated the software delivery lifecycle using a declarative Jenkins CI/CD pipeline, incorporating Trivy container security scans and automated Docker Hub distribution.</a:t>
+            </a:r>
+          </a:p>
+          <a:p>
+            <a:pPr>
+              <a:defRPr sz="1400">
+                <a:solidFill>
+                  <a:srgbClr val="FFFFFF"/>
+                </a:solidFill>
+                <a:latin typeface="Aptos"/>
+              </a:defRPr>
+            </a:pPr>
+            <a:r>
+              <a:t>Solved real-world DevOps challenges including database persistence, network port conflicts, credential separation via Kubernetes Secrets, and zero-downtime rolling releases.</a:t>
+            </a:r>
+          </a:p>
+          <a:p>
+            <a:pPr>
+              <a:defRPr sz="1400">
+                <a:solidFill>
+                  <a:srgbClr val="FFFFFF"/>
+                </a:solidFill>
+                <a:latin typeface="Aptos"/>
+              </a:defRPr>
+            </a:pPr>
+            <a:r>
+              <a:t>The project successfully demonstrates end-to-end cloud engineering, DevSecOps automation, and high-availability application hosting on Amazon Web Services.</a:t>
+            </a:r>
           </a:p>
         </p:txBody>
       </p:sp>
@@ -18675,6 +18208,1678 @@
         <p14:creationId xmlns:p14="http://schemas.microsoft.com/office/powerpoint/2010/main" val="2602928035"/>
       </p:ext>
     </p:extLst>
+  </p:cSld>
+  <p:clrMapOvr>
+    <a:masterClrMapping/>
+  </p:clrMapOvr>
+</p:sld>
+</file>
+
+<file path=ppt/slides/slide22.xml><?xml version="1.0" encoding="utf-8"?>
+<p:sld xmlns:a="http://schemas.openxmlformats.org/drawingml/2006/main" xmlns:p="http://schemas.openxmlformats.org/presentationml/2006/main" xmlns:r="http://schemas.openxmlformats.org/officeDocument/2006/relationships">
+  <p:cSld>
+    <p:bg>
+      <p:bgPr>
+        <a:solidFill>
+          <a:srgbClr val="14082D"/>
+        </a:solidFill>
+        <a:effectLst/>
+      </p:bgPr>
+    </p:bg>
+    <p:spTree>
+      <p:nvGrpSpPr>
+        <p:cNvPr id="1" name=""/>
+        <p:cNvGrpSpPr/>
+        <p:nvPr/>
+      </p:nvGrpSpPr>
+      <p:grpSpPr/>
+      <p:sp>
+        <p:nvSpPr>
+          <p:cNvPr id="2" name="TextBox 1"/>
+          <p:cNvSpPr txBox="1"/>
+          <p:nvPr/>
+        </p:nvSpPr>
+        <p:spPr>
+          <a:xfrm>
+            <a:off x="594360" y="320040"/>
+            <a:ext cx="10972800" cy="594360"/>
+          </a:xfrm>
+          <a:prstGeom prst="rect">
+            <a:avLst/>
+          </a:prstGeom>
+          <a:noFill/>
+        </p:spPr>
+        <p:txBody>
+          <a:bodyPr wrap="none">
+            <a:spAutoFit/>
+          </a:bodyPr>
+          <a:lstStyle/>
+          <a:p>
+            <a:pPr>
+              <a:defRPr sz="2800" b="1">
+                <a:solidFill>
+                  <a:srgbClr val="FFFFFF"/>
+                </a:solidFill>
+                <a:latin typeface="Aptos Display"/>
+              </a:defRPr>
+            </a:pPr>
+            <a:r>
+              <a:t>Jenkins CI/CD &amp; DevSecOps Pipeline</a:t>
+            </a:r>
+          </a:p>
+        </p:txBody>
+      </p:sp>
+      <p:sp>
+        <p:nvSpPr>
+          <p:cNvPr id="3" name="TextBox 2"/>
+          <p:cNvSpPr txBox="1"/>
+          <p:nvPr/>
+        </p:nvSpPr>
+        <p:spPr>
+          <a:xfrm>
+            <a:off x="621792" y="932688"/>
+            <a:ext cx="10698480" cy="365760"/>
+          </a:xfrm>
+          <a:prstGeom prst="rect">
+            <a:avLst/>
+          </a:prstGeom>
+          <a:noFill/>
+        </p:spPr>
+        <p:txBody>
+          <a:bodyPr wrap="none">
+            <a:spAutoFit/>
+          </a:bodyPr>
+          <a:lstStyle/>
+          <a:p>
+            <a:pPr>
+              <a:defRPr sz="1200">
+                <a:solidFill>
+                  <a:srgbClr val="BEB2DC"/>
+                </a:solidFill>
+                <a:latin typeface="Aptos"/>
+              </a:defRPr>
+            </a:pPr>
+            <a:r>
+              <a:t>End-to-end continuous integration, vulnerability scanning, and automated delivery workflow</a:t>
+            </a:r>
+          </a:p>
+        </p:txBody>
+      </p:sp>
+      <p:sp>
+        <p:nvSpPr>
+          <p:cNvPr id="4" name="Rounded Rectangle 3"/>
+          <p:cNvSpPr/>
+          <p:nvPr/>
+        </p:nvSpPr>
+        <p:spPr>
+          <a:xfrm>
+            <a:off x="640080" y="1325880"/>
+            <a:ext cx="3429000" cy="1874519"/>
+          </a:xfrm>
+          <a:prstGeom prst="roundRect">
+            <a:avLst/>
+          </a:prstGeom>
+          <a:solidFill>
+            <a:srgbClr val="26114C"/>
+          </a:solidFill>
+          <a:ln w="19050">
+            <a:solidFill>
+              <a:srgbClr val="4E97EB"/>
+            </a:solidFill>
+          </a:ln>
+        </p:spPr>
+        <p:style>
+          <a:lnRef idx="1">
+            <a:schemeClr val="accent1"/>
+          </a:lnRef>
+          <a:fillRef idx="3">
+            <a:schemeClr val="accent1"/>
+          </a:fillRef>
+          <a:effectRef idx="2">
+            <a:schemeClr val="accent1"/>
+          </a:effectRef>
+          <a:fontRef idx="minor">
+            <a:schemeClr val="lt1"/>
+          </a:fontRef>
+        </p:style>
+        <p:txBody>
+          <a:bodyPr rtlCol="0" anchor="ctr"/>
+          <a:lstStyle/>
+          <a:p>
+            <a:pPr algn="ctr"/>
+          </a:p>
+        </p:txBody>
+      </p:sp>
+      <p:sp>
+        <p:nvSpPr>
+          <p:cNvPr id="5" name="TextBox 4"/>
+          <p:cNvSpPr txBox="1"/>
+          <p:nvPr/>
+        </p:nvSpPr>
+        <p:spPr>
+          <a:xfrm>
+            <a:off x="804671" y="1444752"/>
+            <a:ext cx="3108960" cy="347472"/>
+          </a:xfrm>
+          <a:prstGeom prst="rect">
+            <a:avLst/>
+          </a:prstGeom>
+          <a:noFill/>
+        </p:spPr>
+        <p:txBody>
+          <a:bodyPr wrap="square">
+            <a:spAutoFit/>
+          </a:bodyPr>
+          <a:lstStyle/>
+          <a:p>
+            <a:pPr>
+              <a:defRPr sz="1400" b="1">
+                <a:solidFill>
+                  <a:srgbClr val="FFFFFF"/>
+                </a:solidFill>
+                <a:latin typeface="Aptos"/>
+              </a:defRPr>
+            </a:pPr>
+            <a:r>
+              <a:t>Stage 1: SCM Checkout</a:t>
+            </a:r>
+          </a:p>
+        </p:txBody>
+      </p:sp>
+      <p:sp>
+        <p:nvSpPr>
+          <p:cNvPr id="6" name="TextBox 5"/>
+          <p:cNvSpPr txBox="1"/>
+          <p:nvPr/>
+        </p:nvSpPr>
+        <p:spPr>
+          <a:xfrm>
+            <a:off x="804671" y="1828800"/>
+            <a:ext cx="3108960" cy="1252727"/>
+          </a:xfrm>
+          <a:prstGeom prst="rect">
+            <a:avLst/>
+          </a:prstGeom>
+          <a:noFill/>
+        </p:spPr>
+        <p:txBody>
+          <a:bodyPr wrap="square">
+            <a:spAutoFit/>
+          </a:bodyPr>
+          <a:lstStyle/>
+          <a:p>
+            <a:pPr>
+              <a:defRPr sz="1000">
+                <a:solidFill>
+                  <a:srgbClr val="EBE5FA"/>
+                </a:solidFill>
+                <a:latin typeface="Aptos"/>
+              </a:defRPr>
+            </a:pPr>
+            <a:r>
+              <a:t>Polls GitHub repository every 60s; triggers declarative pipeline immediately upon commit to main branch.</a:t>
+            </a:r>
+          </a:p>
+        </p:txBody>
+      </p:sp>
+      <p:sp>
+        <p:nvSpPr>
+          <p:cNvPr id="7" name="Rounded Rectangle 6"/>
+          <p:cNvSpPr/>
+          <p:nvPr/>
+        </p:nvSpPr>
+        <p:spPr>
+          <a:xfrm>
+            <a:off x="4389120" y="1325880"/>
+            <a:ext cx="3429000" cy="1874519"/>
+          </a:xfrm>
+          <a:prstGeom prst="roundRect">
+            <a:avLst/>
+          </a:prstGeom>
+          <a:solidFill>
+            <a:srgbClr val="26114C"/>
+          </a:solidFill>
+          <a:ln w="19050">
+            <a:solidFill>
+              <a:srgbClr val="4E97EB"/>
+            </a:solidFill>
+          </a:ln>
+        </p:spPr>
+        <p:style>
+          <a:lnRef idx="1">
+            <a:schemeClr val="accent1"/>
+          </a:lnRef>
+          <a:fillRef idx="3">
+            <a:schemeClr val="accent1"/>
+          </a:fillRef>
+          <a:effectRef idx="2">
+            <a:schemeClr val="accent1"/>
+          </a:effectRef>
+          <a:fontRef idx="minor">
+            <a:schemeClr val="lt1"/>
+          </a:fontRef>
+        </p:style>
+        <p:txBody>
+          <a:bodyPr rtlCol="0" anchor="ctr"/>
+          <a:lstStyle/>
+          <a:p>
+            <a:pPr algn="ctr"/>
+          </a:p>
+        </p:txBody>
+      </p:sp>
+      <p:sp>
+        <p:nvSpPr>
+          <p:cNvPr id="8" name="TextBox 7"/>
+          <p:cNvSpPr txBox="1"/>
+          <p:nvPr/>
+        </p:nvSpPr>
+        <p:spPr>
+          <a:xfrm>
+            <a:off x="4553711" y="1444752"/>
+            <a:ext cx="3108960" cy="347472"/>
+          </a:xfrm>
+          <a:prstGeom prst="rect">
+            <a:avLst/>
+          </a:prstGeom>
+          <a:noFill/>
+        </p:spPr>
+        <p:txBody>
+          <a:bodyPr wrap="square">
+            <a:spAutoFit/>
+          </a:bodyPr>
+          <a:lstStyle/>
+          <a:p>
+            <a:pPr>
+              <a:defRPr sz="1400" b="1">
+                <a:solidFill>
+                  <a:srgbClr val="FFFFFF"/>
+                </a:solidFill>
+                <a:latin typeface="Aptos"/>
+              </a:defRPr>
+            </a:pPr>
+            <a:r>
+              <a:t>Stage 2: Syntax Linting</a:t>
+            </a:r>
+          </a:p>
+        </p:txBody>
+      </p:sp>
+      <p:sp>
+        <p:nvSpPr>
+          <p:cNvPr id="9" name="TextBox 8"/>
+          <p:cNvSpPr txBox="1"/>
+          <p:nvPr/>
+        </p:nvSpPr>
+        <p:spPr>
+          <a:xfrm>
+            <a:off x="4553711" y="1828800"/>
+            <a:ext cx="3108960" cy="1252727"/>
+          </a:xfrm>
+          <a:prstGeom prst="rect">
+            <a:avLst/>
+          </a:prstGeom>
+          <a:noFill/>
+        </p:spPr>
+        <p:txBody>
+          <a:bodyPr wrap="square">
+            <a:spAutoFit/>
+          </a:bodyPr>
+          <a:lstStyle/>
+          <a:p>
+            <a:pPr>
+              <a:defRPr sz="1000">
+                <a:solidFill>
+                  <a:srgbClr val="EBE5FA"/>
+                </a:solidFill>
+                <a:latin typeface="Aptos"/>
+              </a:defRPr>
+            </a:pPr>
+            <a:r>
+              <a:t>Automated pre-flight syntax validation (php -l) verifies code integrity before building, preventing broken deployments.</a:t>
+            </a:r>
+          </a:p>
+        </p:txBody>
+      </p:sp>
+      <p:sp>
+        <p:nvSpPr>
+          <p:cNvPr id="10" name="Rounded Rectangle 9"/>
+          <p:cNvSpPr/>
+          <p:nvPr/>
+        </p:nvSpPr>
+        <p:spPr>
+          <a:xfrm>
+            <a:off x="8138160" y="1325880"/>
+            <a:ext cx="3429000" cy="1874519"/>
+          </a:xfrm>
+          <a:prstGeom prst="roundRect">
+            <a:avLst/>
+          </a:prstGeom>
+          <a:solidFill>
+            <a:srgbClr val="26114C"/>
+          </a:solidFill>
+          <a:ln w="19050">
+            <a:solidFill>
+              <a:srgbClr val="4E97EB"/>
+            </a:solidFill>
+          </a:ln>
+        </p:spPr>
+        <p:style>
+          <a:lnRef idx="1">
+            <a:schemeClr val="accent1"/>
+          </a:lnRef>
+          <a:fillRef idx="3">
+            <a:schemeClr val="accent1"/>
+          </a:fillRef>
+          <a:effectRef idx="2">
+            <a:schemeClr val="accent1"/>
+          </a:effectRef>
+          <a:fontRef idx="minor">
+            <a:schemeClr val="lt1"/>
+          </a:fontRef>
+        </p:style>
+        <p:txBody>
+          <a:bodyPr rtlCol="0" anchor="ctr"/>
+          <a:lstStyle/>
+          <a:p>
+            <a:pPr algn="ctr"/>
+          </a:p>
+        </p:txBody>
+      </p:sp>
+      <p:sp>
+        <p:nvSpPr>
+          <p:cNvPr id="11" name="TextBox 10"/>
+          <p:cNvSpPr txBox="1"/>
+          <p:nvPr/>
+        </p:nvSpPr>
+        <p:spPr>
+          <a:xfrm>
+            <a:off x="8302751" y="1444752"/>
+            <a:ext cx="3108960" cy="347472"/>
+          </a:xfrm>
+          <a:prstGeom prst="rect">
+            <a:avLst/>
+          </a:prstGeom>
+          <a:noFill/>
+        </p:spPr>
+        <p:txBody>
+          <a:bodyPr wrap="square">
+            <a:spAutoFit/>
+          </a:bodyPr>
+          <a:lstStyle/>
+          <a:p>
+            <a:pPr>
+              <a:defRPr sz="1400" b="1">
+                <a:solidFill>
+                  <a:srgbClr val="FFFFFF"/>
+                </a:solidFill>
+                <a:latin typeface="Aptos"/>
+              </a:defRPr>
+            </a:pPr>
+            <a:r>
+              <a:t>Stage 3: Docker Build &amp; Tag</a:t>
+            </a:r>
+          </a:p>
+        </p:txBody>
+      </p:sp>
+      <p:sp>
+        <p:nvSpPr>
+          <p:cNvPr id="12" name="TextBox 11"/>
+          <p:cNvSpPr txBox="1"/>
+          <p:nvPr/>
+        </p:nvSpPr>
+        <p:spPr>
+          <a:xfrm>
+            <a:off x="8302751" y="1828800"/>
+            <a:ext cx="3108960" cy="1252727"/>
+          </a:xfrm>
+          <a:prstGeom prst="rect">
+            <a:avLst/>
+          </a:prstGeom>
+          <a:noFill/>
+        </p:spPr>
+        <p:txBody>
+          <a:bodyPr wrap="square">
+            <a:spAutoFit/>
+          </a:bodyPr>
+          <a:lstStyle/>
+          <a:p>
+            <a:pPr>
+              <a:defRPr sz="1000">
+                <a:solidFill>
+                  <a:srgbClr val="EBE5FA"/>
+                </a:solidFill>
+                <a:latin typeface="Aptos"/>
+              </a:defRPr>
+            </a:pPr>
+            <a:r>
+              <a:t>Builds production container image and applies unique semantic tags using Jenkins ${BUILD_NUMBER} for complete traceability.</a:t>
+            </a:r>
+          </a:p>
+        </p:txBody>
+      </p:sp>
+      <p:sp>
+        <p:nvSpPr>
+          <p:cNvPr id="13" name="Rounded Rectangle 12"/>
+          <p:cNvSpPr/>
+          <p:nvPr/>
+        </p:nvSpPr>
+        <p:spPr>
+          <a:xfrm>
+            <a:off x="640080" y="3566160"/>
+            <a:ext cx="3429000" cy="1874519"/>
+          </a:xfrm>
+          <a:prstGeom prst="roundRect">
+            <a:avLst/>
+          </a:prstGeom>
+          <a:solidFill>
+            <a:srgbClr val="26114C"/>
+          </a:solidFill>
+          <a:ln w="19050">
+            <a:solidFill>
+              <a:srgbClr val="4E97EB"/>
+            </a:solidFill>
+          </a:ln>
+        </p:spPr>
+        <p:style>
+          <a:lnRef idx="1">
+            <a:schemeClr val="accent1"/>
+          </a:lnRef>
+          <a:fillRef idx="3">
+            <a:schemeClr val="accent1"/>
+          </a:fillRef>
+          <a:effectRef idx="2">
+            <a:schemeClr val="accent1"/>
+          </a:effectRef>
+          <a:fontRef idx="minor">
+            <a:schemeClr val="lt1"/>
+          </a:fontRef>
+        </p:style>
+        <p:txBody>
+          <a:bodyPr rtlCol="0" anchor="ctr"/>
+          <a:lstStyle/>
+          <a:p>
+            <a:pPr algn="ctr"/>
+          </a:p>
+        </p:txBody>
+      </p:sp>
+      <p:sp>
+        <p:nvSpPr>
+          <p:cNvPr id="14" name="TextBox 13"/>
+          <p:cNvSpPr txBox="1"/>
+          <p:nvPr/>
+        </p:nvSpPr>
+        <p:spPr>
+          <a:xfrm>
+            <a:off x="804671" y="3685032"/>
+            <a:ext cx="3108960" cy="347472"/>
+          </a:xfrm>
+          <a:prstGeom prst="rect">
+            <a:avLst/>
+          </a:prstGeom>
+          <a:noFill/>
+        </p:spPr>
+        <p:txBody>
+          <a:bodyPr wrap="square">
+            <a:spAutoFit/>
+          </a:bodyPr>
+          <a:lstStyle/>
+          <a:p>
+            <a:pPr>
+              <a:defRPr sz="1400" b="1">
+                <a:solidFill>
+                  <a:srgbClr val="FFFFFF"/>
+                </a:solidFill>
+                <a:latin typeface="Aptos"/>
+              </a:defRPr>
+            </a:pPr>
+            <a:r>
+              <a:t>Stage 4: DevSecOps Trivy Scan</a:t>
+            </a:r>
+          </a:p>
+        </p:txBody>
+      </p:sp>
+      <p:sp>
+        <p:nvSpPr>
+          <p:cNvPr id="15" name="TextBox 14"/>
+          <p:cNvSpPr txBox="1"/>
+          <p:nvPr/>
+        </p:nvSpPr>
+        <p:spPr>
+          <a:xfrm>
+            <a:off x="804671" y="4069080"/>
+            <a:ext cx="3108960" cy="1252727"/>
+          </a:xfrm>
+          <a:prstGeom prst="rect">
+            <a:avLst/>
+          </a:prstGeom>
+          <a:noFill/>
+        </p:spPr>
+        <p:txBody>
+          <a:bodyPr wrap="square">
+            <a:spAutoFit/>
+          </a:bodyPr>
+          <a:lstStyle/>
+          <a:p>
+            <a:pPr>
+              <a:defRPr sz="1000">
+                <a:solidFill>
+                  <a:srgbClr val="EBE5FA"/>
+                </a:solidFill>
+                <a:latin typeface="Aptos"/>
+              </a:defRPr>
+            </a:pPr>
+            <a:r>
+              <a:t>Trivy scanner checks container filesystem for CVEs, generating audit reports and failing build on CRITICAL severity.</a:t>
+            </a:r>
+          </a:p>
+        </p:txBody>
+      </p:sp>
+      <p:sp>
+        <p:nvSpPr>
+          <p:cNvPr id="16" name="Rounded Rectangle 15"/>
+          <p:cNvSpPr/>
+          <p:nvPr/>
+        </p:nvSpPr>
+        <p:spPr>
+          <a:xfrm>
+            <a:off x="4389120" y="3566160"/>
+            <a:ext cx="3429000" cy="1874519"/>
+          </a:xfrm>
+          <a:prstGeom prst="roundRect">
+            <a:avLst/>
+          </a:prstGeom>
+          <a:solidFill>
+            <a:srgbClr val="26114C"/>
+          </a:solidFill>
+          <a:ln w="19050">
+            <a:solidFill>
+              <a:srgbClr val="4E97EB"/>
+            </a:solidFill>
+          </a:ln>
+        </p:spPr>
+        <p:style>
+          <a:lnRef idx="1">
+            <a:schemeClr val="accent1"/>
+          </a:lnRef>
+          <a:fillRef idx="3">
+            <a:schemeClr val="accent1"/>
+          </a:fillRef>
+          <a:effectRef idx="2">
+            <a:schemeClr val="accent1"/>
+          </a:effectRef>
+          <a:fontRef idx="minor">
+            <a:schemeClr val="lt1"/>
+          </a:fontRef>
+        </p:style>
+        <p:txBody>
+          <a:bodyPr rtlCol="0" anchor="ctr"/>
+          <a:lstStyle/>
+          <a:p>
+            <a:pPr algn="ctr"/>
+          </a:p>
+        </p:txBody>
+      </p:sp>
+      <p:sp>
+        <p:nvSpPr>
+          <p:cNvPr id="17" name="TextBox 16"/>
+          <p:cNvSpPr txBox="1"/>
+          <p:nvPr/>
+        </p:nvSpPr>
+        <p:spPr>
+          <a:xfrm>
+            <a:off x="4553711" y="3685032"/>
+            <a:ext cx="3108960" cy="347472"/>
+          </a:xfrm>
+          <a:prstGeom prst="rect">
+            <a:avLst/>
+          </a:prstGeom>
+          <a:noFill/>
+        </p:spPr>
+        <p:txBody>
+          <a:bodyPr wrap="square">
+            <a:spAutoFit/>
+          </a:bodyPr>
+          <a:lstStyle/>
+          <a:p>
+            <a:pPr>
+              <a:defRPr sz="1400" b="1">
+                <a:solidFill>
+                  <a:srgbClr val="FFFFFF"/>
+                </a:solidFill>
+                <a:latin typeface="Aptos"/>
+              </a:defRPr>
+            </a:pPr>
+            <a:r>
+              <a:t>Stage 5: Secure Hub Push</a:t>
+            </a:r>
+          </a:p>
+        </p:txBody>
+      </p:sp>
+      <p:sp>
+        <p:nvSpPr>
+          <p:cNvPr id="18" name="TextBox 17"/>
+          <p:cNvSpPr txBox="1"/>
+          <p:nvPr/>
+        </p:nvSpPr>
+        <p:spPr>
+          <a:xfrm>
+            <a:off x="4553711" y="4069080"/>
+            <a:ext cx="3108960" cy="1252727"/>
+          </a:xfrm>
+          <a:prstGeom prst="rect">
+            <a:avLst/>
+          </a:prstGeom>
+          <a:noFill/>
+        </p:spPr>
+        <p:txBody>
+          <a:bodyPr wrap="square">
+            <a:spAutoFit/>
+          </a:bodyPr>
+          <a:lstStyle/>
+          <a:p>
+            <a:pPr>
+              <a:defRPr sz="1000">
+                <a:solidFill>
+                  <a:srgbClr val="EBE5FA"/>
+                </a:solidFill>
+                <a:latin typeface="Aptos"/>
+              </a:defRPr>
+            </a:pPr>
+            <a:r>
+              <a:t>Pushes scanned, verified container image to Docker Hub repository (vaibhavmungal/votesecure-app) via Jenkins credentials.</a:t>
+            </a:r>
+          </a:p>
+        </p:txBody>
+      </p:sp>
+      <p:sp>
+        <p:nvSpPr>
+          <p:cNvPr id="19" name="Rounded Rectangle 18"/>
+          <p:cNvSpPr/>
+          <p:nvPr/>
+        </p:nvSpPr>
+        <p:spPr>
+          <a:xfrm>
+            <a:off x="8138160" y="3566160"/>
+            <a:ext cx="3429000" cy="1874519"/>
+          </a:xfrm>
+          <a:prstGeom prst="roundRect">
+            <a:avLst/>
+          </a:prstGeom>
+          <a:solidFill>
+            <a:srgbClr val="26114C"/>
+          </a:solidFill>
+          <a:ln w="19050">
+            <a:solidFill>
+              <a:srgbClr val="4E97EB"/>
+            </a:solidFill>
+          </a:ln>
+        </p:spPr>
+        <p:style>
+          <a:lnRef idx="1">
+            <a:schemeClr val="accent1"/>
+          </a:lnRef>
+          <a:fillRef idx="3">
+            <a:schemeClr val="accent1"/>
+          </a:fillRef>
+          <a:effectRef idx="2">
+            <a:schemeClr val="accent1"/>
+          </a:effectRef>
+          <a:fontRef idx="minor">
+            <a:schemeClr val="lt1"/>
+          </a:fontRef>
+        </p:style>
+        <p:txBody>
+          <a:bodyPr rtlCol="0" anchor="ctr"/>
+          <a:lstStyle/>
+          <a:p>
+            <a:pPr algn="ctr"/>
+          </a:p>
+        </p:txBody>
+      </p:sp>
+      <p:sp>
+        <p:nvSpPr>
+          <p:cNvPr id="20" name="TextBox 19"/>
+          <p:cNvSpPr txBox="1"/>
+          <p:nvPr/>
+        </p:nvSpPr>
+        <p:spPr>
+          <a:xfrm>
+            <a:off x="8302751" y="3685032"/>
+            <a:ext cx="3108960" cy="347472"/>
+          </a:xfrm>
+          <a:prstGeom prst="rect">
+            <a:avLst/>
+          </a:prstGeom>
+          <a:noFill/>
+        </p:spPr>
+        <p:txBody>
+          <a:bodyPr wrap="square">
+            <a:spAutoFit/>
+          </a:bodyPr>
+          <a:lstStyle/>
+          <a:p>
+            <a:pPr>
+              <a:defRPr sz="1400" b="1">
+                <a:solidFill>
+                  <a:srgbClr val="FFFFFF"/>
+                </a:solidFill>
+                <a:latin typeface="Aptos"/>
+              </a:defRPr>
+            </a:pPr>
+            <a:r>
+              <a:t>Stage 6: Zero-Downtime Deploy</a:t>
+            </a:r>
+          </a:p>
+        </p:txBody>
+      </p:sp>
+      <p:sp>
+        <p:nvSpPr>
+          <p:cNvPr id="21" name="TextBox 20"/>
+          <p:cNvSpPr txBox="1"/>
+          <p:nvPr/>
+        </p:nvSpPr>
+        <p:spPr>
+          <a:xfrm>
+            <a:off x="8302751" y="4069080"/>
+            <a:ext cx="3108960" cy="1252727"/>
+          </a:xfrm>
+          <a:prstGeom prst="rect">
+            <a:avLst/>
+          </a:prstGeom>
+          <a:noFill/>
+        </p:spPr>
+        <p:txBody>
+          <a:bodyPr wrap="square">
+            <a:spAutoFit/>
+          </a:bodyPr>
+          <a:lstStyle/>
+          <a:p>
+            <a:pPr>
+              <a:defRPr sz="1000">
+                <a:solidFill>
+                  <a:srgbClr val="EBE5FA"/>
+                </a:solidFill>
+                <a:latin typeface="Aptos"/>
+              </a:defRPr>
+            </a:pPr>
+            <a:r>
+              <a:t>Executes zero-downtime rolling update on Amazon EKS cluster and validates deployment using /health.php smoke test.</a:t>
+            </a:r>
+          </a:p>
+        </p:txBody>
+      </p:sp>
+      <p:sp>
+        <p:nvSpPr>
+          <p:cNvPr id="22" name="TextBox 21"/>
+          <p:cNvSpPr txBox="1"/>
+          <p:nvPr/>
+        </p:nvSpPr>
+        <p:spPr>
+          <a:xfrm>
+            <a:off x="594360" y="6565392"/>
+            <a:ext cx="10972800" cy="182880"/>
+          </a:xfrm>
+          <a:prstGeom prst="rect">
+            <a:avLst/>
+          </a:prstGeom>
+          <a:noFill/>
+        </p:spPr>
+        <p:txBody>
+          <a:bodyPr wrap="none">
+            <a:spAutoFit/>
+          </a:bodyPr>
+          <a:lstStyle/>
+          <a:p>
+            <a:pPr>
+              <a:defRPr sz="900">
+                <a:solidFill>
+                  <a:srgbClr val="BEB2DC"/>
+                </a:solidFill>
+                <a:latin typeface="Aptos"/>
+              </a:defRPr>
+            </a:pPr>
+            <a:r>
+              <a:t>VoteSecure • DevOps &amp; CI/CD Pipeline • 23</a:t>
+            </a:r>
+          </a:p>
+        </p:txBody>
+      </p:sp>
+    </p:spTree>
+  </p:cSld>
+  <p:clrMapOvr>
+    <a:masterClrMapping/>
+  </p:clrMapOvr>
+</p:sld>
+</file>
+
+<file path=ppt/slides/slide23.xml><?xml version="1.0" encoding="utf-8"?>
+<p:sld xmlns:a="http://schemas.openxmlformats.org/drawingml/2006/main" xmlns:p="http://schemas.openxmlformats.org/presentationml/2006/main" xmlns:r="http://schemas.openxmlformats.org/officeDocument/2006/relationships">
+  <p:cSld>
+    <p:bg>
+      <p:bgPr>
+        <a:solidFill>
+          <a:srgbClr val="14082D"/>
+        </a:solidFill>
+        <a:effectLst/>
+      </p:bgPr>
+    </p:bg>
+    <p:spTree>
+      <p:nvGrpSpPr>
+        <p:cNvPr id="1" name=""/>
+        <p:cNvGrpSpPr/>
+        <p:nvPr/>
+      </p:nvGrpSpPr>
+      <p:grpSpPr/>
+      <p:sp>
+        <p:nvSpPr>
+          <p:cNvPr id="2" name="TextBox 1"/>
+          <p:cNvSpPr txBox="1"/>
+          <p:nvPr/>
+        </p:nvSpPr>
+        <p:spPr>
+          <a:xfrm>
+            <a:off x="594360" y="320040"/>
+            <a:ext cx="10972800" cy="594360"/>
+          </a:xfrm>
+          <a:prstGeom prst="rect">
+            <a:avLst/>
+          </a:prstGeom>
+          <a:noFill/>
+        </p:spPr>
+        <p:txBody>
+          <a:bodyPr wrap="none">
+            <a:spAutoFit/>
+          </a:bodyPr>
+          <a:lstStyle/>
+          <a:p>
+            <a:pPr>
+              <a:defRPr sz="2800" b="1">
+                <a:solidFill>
+                  <a:srgbClr val="FFFFFF"/>
+                </a:solidFill>
+                <a:latin typeface="Aptos Display"/>
+              </a:defRPr>
+            </a:pPr>
+            <a:r>
+              <a:t>Network Architecture &amp; Port Governance</a:t>
+            </a:r>
+          </a:p>
+        </p:txBody>
+      </p:sp>
+      <p:sp>
+        <p:nvSpPr>
+          <p:cNvPr id="3" name="TextBox 2"/>
+          <p:cNvSpPr txBox="1"/>
+          <p:nvPr/>
+        </p:nvSpPr>
+        <p:spPr>
+          <a:xfrm>
+            <a:off x="621792" y="932688"/>
+            <a:ext cx="10698480" cy="365760"/>
+          </a:xfrm>
+          <a:prstGeom prst="rect">
+            <a:avLst/>
+          </a:prstGeom>
+          <a:noFill/>
+        </p:spPr>
+        <p:txBody>
+          <a:bodyPr wrap="none">
+            <a:spAutoFit/>
+          </a:bodyPr>
+          <a:lstStyle/>
+          <a:p>
+            <a:pPr>
+              <a:defRPr sz="1200">
+                <a:solidFill>
+                  <a:srgbClr val="BEB2DC"/>
+                </a:solidFill>
+                <a:latin typeface="Aptos"/>
+              </a:defRPr>
+            </a:pPr>
+            <a:r>
+              <a:t>Enterprise network segregation, security groups, and zero-conflict allocation</a:t>
+            </a:r>
+          </a:p>
+        </p:txBody>
+      </p:sp>
+      <p:sp>
+        <p:nvSpPr>
+          <p:cNvPr id="4" name="Rounded Rectangle 3"/>
+          <p:cNvSpPr/>
+          <p:nvPr/>
+        </p:nvSpPr>
+        <p:spPr>
+          <a:xfrm>
+            <a:off x="640080" y="1325880"/>
+            <a:ext cx="3429000" cy="1874519"/>
+          </a:xfrm>
+          <a:prstGeom prst="roundRect">
+            <a:avLst/>
+          </a:prstGeom>
+          <a:solidFill>
+            <a:srgbClr val="26114C"/>
+          </a:solidFill>
+          <a:ln w="19050">
+            <a:solidFill>
+              <a:srgbClr val="4E97EB"/>
+            </a:solidFill>
+          </a:ln>
+        </p:spPr>
+        <p:style>
+          <a:lnRef idx="1">
+            <a:schemeClr val="accent1"/>
+          </a:lnRef>
+          <a:fillRef idx="3">
+            <a:schemeClr val="accent1"/>
+          </a:fillRef>
+          <a:effectRef idx="2">
+            <a:schemeClr val="accent1"/>
+          </a:effectRef>
+          <a:fontRef idx="minor">
+            <a:schemeClr val="lt1"/>
+          </a:fontRef>
+        </p:style>
+        <p:txBody>
+          <a:bodyPr rtlCol="0" anchor="ctr"/>
+          <a:lstStyle/>
+          <a:p>
+            <a:pPr algn="ctr"/>
+          </a:p>
+        </p:txBody>
+      </p:sp>
+      <p:sp>
+        <p:nvSpPr>
+          <p:cNvPr id="5" name="TextBox 4"/>
+          <p:cNvSpPr txBox="1"/>
+          <p:nvPr/>
+        </p:nvSpPr>
+        <p:spPr>
+          <a:xfrm>
+            <a:off x="804671" y="1444752"/>
+            <a:ext cx="3108960" cy="347472"/>
+          </a:xfrm>
+          <a:prstGeom prst="rect">
+            <a:avLst/>
+          </a:prstGeom>
+          <a:noFill/>
+        </p:spPr>
+        <p:txBody>
+          <a:bodyPr wrap="square">
+            <a:spAutoFit/>
+          </a:bodyPr>
+          <a:lstStyle/>
+          <a:p>
+            <a:pPr>
+              <a:defRPr sz="1400" b="1">
+                <a:solidFill>
+                  <a:srgbClr val="FFFFFF"/>
+                </a:solidFill>
+                <a:latin typeface="Aptos"/>
+              </a:defRPr>
+            </a:pPr>
+            <a:r>
+              <a:t>Port 80 (Production HTTP)</a:t>
+            </a:r>
+          </a:p>
+        </p:txBody>
+      </p:sp>
+      <p:sp>
+        <p:nvSpPr>
+          <p:cNvPr id="6" name="TextBox 5"/>
+          <p:cNvSpPr txBox="1"/>
+          <p:nvPr/>
+        </p:nvSpPr>
+        <p:spPr>
+          <a:xfrm>
+            <a:off x="804671" y="1828800"/>
+            <a:ext cx="3108960" cy="1252727"/>
+          </a:xfrm>
+          <a:prstGeom prst="rect">
+            <a:avLst/>
+          </a:prstGeom>
+          <a:noFill/>
+        </p:spPr>
+        <p:txBody>
+          <a:bodyPr wrap="square">
+            <a:spAutoFit/>
+          </a:bodyPr>
+          <a:lstStyle/>
+          <a:p>
+            <a:pPr>
+              <a:defRPr sz="1000">
+                <a:solidFill>
+                  <a:srgbClr val="EBE5FA"/>
+                </a:solidFill>
+                <a:latin typeface="Aptos"/>
+              </a:defRPr>
+            </a:pPr>
+            <a:r>
+              <a:t>AWS Elastic Load Balancer (ELB) receives public voter traffic and routes to healthy Kubernetes App Pods across AZs.</a:t>
+            </a:r>
+          </a:p>
+        </p:txBody>
+      </p:sp>
+      <p:sp>
+        <p:nvSpPr>
+          <p:cNvPr id="7" name="Rounded Rectangle 6"/>
+          <p:cNvSpPr/>
+          <p:nvPr/>
+        </p:nvSpPr>
+        <p:spPr>
+          <a:xfrm>
+            <a:off x="4389120" y="1325880"/>
+            <a:ext cx="3429000" cy="1874519"/>
+          </a:xfrm>
+          <a:prstGeom prst="roundRect">
+            <a:avLst/>
+          </a:prstGeom>
+          <a:solidFill>
+            <a:srgbClr val="26114C"/>
+          </a:solidFill>
+          <a:ln w="19050">
+            <a:solidFill>
+              <a:srgbClr val="4E97EB"/>
+            </a:solidFill>
+          </a:ln>
+        </p:spPr>
+        <p:style>
+          <a:lnRef idx="1">
+            <a:schemeClr val="accent1"/>
+          </a:lnRef>
+          <a:fillRef idx="3">
+            <a:schemeClr val="accent1"/>
+          </a:fillRef>
+          <a:effectRef idx="2">
+            <a:schemeClr val="accent1"/>
+          </a:effectRef>
+          <a:fontRef idx="minor">
+            <a:schemeClr val="lt1"/>
+          </a:fontRef>
+        </p:style>
+        <p:txBody>
+          <a:bodyPr rtlCol="0" anchor="ctr"/>
+          <a:lstStyle/>
+          <a:p>
+            <a:pPr algn="ctr"/>
+          </a:p>
+        </p:txBody>
+      </p:sp>
+      <p:sp>
+        <p:nvSpPr>
+          <p:cNvPr id="8" name="TextBox 7"/>
+          <p:cNvSpPr txBox="1"/>
+          <p:nvPr/>
+        </p:nvSpPr>
+        <p:spPr>
+          <a:xfrm>
+            <a:off x="4553711" y="1444752"/>
+            <a:ext cx="3108960" cy="347472"/>
+          </a:xfrm>
+          <a:prstGeom prst="rect">
+            <a:avLst/>
+          </a:prstGeom>
+          <a:noFill/>
+        </p:spPr>
+        <p:txBody>
+          <a:bodyPr wrap="square">
+            <a:spAutoFit/>
+          </a:bodyPr>
+          <a:lstStyle/>
+          <a:p>
+            <a:pPr>
+              <a:defRPr sz="1400" b="1">
+                <a:solidFill>
+                  <a:srgbClr val="FFFFFF"/>
+                </a:solidFill>
+                <a:latin typeface="Aptos"/>
+              </a:defRPr>
+            </a:pPr>
+            <a:r>
+              <a:t>Port 8080 (Dedicated Jenkins)</a:t>
+            </a:r>
+          </a:p>
+        </p:txBody>
+      </p:sp>
+      <p:sp>
+        <p:nvSpPr>
+          <p:cNvPr id="9" name="TextBox 8"/>
+          <p:cNvSpPr txBox="1"/>
+          <p:nvPr/>
+        </p:nvSpPr>
+        <p:spPr>
+          <a:xfrm>
+            <a:off x="4553711" y="1828800"/>
+            <a:ext cx="3108960" cy="1252727"/>
+          </a:xfrm>
+          <a:prstGeom prst="rect">
+            <a:avLst/>
+          </a:prstGeom>
+          <a:noFill/>
+        </p:spPr>
+        <p:txBody>
+          <a:bodyPr wrap="square">
+            <a:spAutoFit/>
+          </a:bodyPr>
+          <a:lstStyle/>
+          <a:p>
+            <a:pPr>
+              <a:defRPr sz="1000">
+                <a:solidFill>
+                  <a:srgbClr val="EBE5FA"/>
+                </a:solidFill>
+                <a:latin typeface="Aptos"/>
+              </a:defRPr>
+            </a:pPr>
+            <a:r>
+              <a:t>Dedicated strictly to Jenkins CI/CD automation server; eliminates port collisions with application web traffic.</a:t>
+            </a:r>
+          </a:p>
+        </p:txBody>
+      </p:sp>
+      <p:sp>
+        <p:nvSpPr>
+          <p:cNvPr id="10" name="Rounded Rectangle 9"/>
+          <p:cNvSpPr/>
+          <p:nvPr/>
+        </p:nvSpPr>
+        <p:spPr>
+          <a:xfrm>
+            <a:off x="8138160" y="1325880"/>
+            <a:ext cx="3429000" cy="1874519"/>
+          </a:xfrm>
+          <a:prstGeom prst="roundRect">
+            <a:avLst/>
+          </a:prstGeom>
+          <a:solidFill>
+            <a:srgbClr val="26114C"/>
+          </a:solidFill>
+          <a:ln w="19050">
+            <a:solidFill>
+              <a:srgbClr val="4E97EB"/>
+            </a:solidFill>
+          </a:ln>
+        </p:spPr>
+        <p:style>
+          <a:lnRef idx="1">
+            <a:schemeClr val="accent1"/>
+          </a:lnRef>
+          <a:fillRef idx="3">
+            <a:schemeClr val="accent1"/>
+          </a:fillRef>
+          <a:effectRef idx="2">
+            <a:schemeClr val="accent1"/>
+          </a:effectRef>
+          <a:fontRef idx="minor">
+            <a:schemeClr val="lt1"/>
+          </a:fontRef>
+        </p:style>
+        <p:txBody>
+          <a:bodyPr rtlCol="0" anchor="ctr"/>
+          <a:lstStyle/>
+          <a:p>
+            <a:pPr algn="ctr"/>
+          </a:p>
+        </p:txBody>
+      </p:sp>
+      <p:sp>
+        <p:nvSpPr>
+          <p:cNvPr id="11" name="TextBox 10"/>
+          <p:cNvSpPr txBox="1"/>
+          <p:nvPr/>
+        </p:nvSpPr>
+        <p:spPr>
+          <a:xfrm>
+            <a:off x="8302751" y="1444752"/>
+            <a:ext cx="3108960" cy="347472"/>
+          </a:xfrm>
+          <a:prstGeom prst="rect">
+            <a:avLst/>
+          </a:prstGeom>
+          <a:noFill/>
+        </p:spPr>
+        <p:txBody>
+          <a:bodyPr wrap="square">
+            <a:spAutoFit/>
+          </a:bodyPr>
+          <a:lstStyle/>
+          <a:p>
+            <a:pPr>
+              <a:defRPr sz="1400" b="1">
+                <a:solidFill>
+                  <a:srgbClr val="FFFFFF"/>
+                </a:solidFill>
+                <a:latin typeface="Aptos"/>
+              </a:defRPr>
+            </a:pPr>
+            <a:r>
+              <a:t>Port 8085 (Docker Compose)</a:t>
+            </a:r>
+          </a:p>
+        </p:txBody>
+      </p:sp>
+      <p:sp>
+        <p:nvSpPr>
+          <p:cNvPr id="12" name="TextBox 11"/>
+          <p:cNvSpPr txBox="1"/>
+          <p:nvPr/>
+        </p:nvSpPr>
+        <p:spPr>
+          <a:xfrm>
+            <a:off x="8302751" y="1828800"/>
+            <a:ext cx="3108960" cy="1252727"/>
+          </a:xfrm>
+          <a:prstGeom prst="rect">
+            <a:avLst/>
+          </a:prstGeom>
+          <a:noFill/>
+        </p:spPr>
+        <p:txBody>
+          <a:bodyPr wrap="square">
+            <a:spAutoFit/>
+          </a:bodyPr>
+          <a:lstStyle/>
+          <a:p>
+            <a:pPr>
+              <a:defRPr sz="1000">
+                <a:solidFill>
+                  <a:srgbClr val="EBE5FA"/>
+                </a:solidFill>
+                <a:latin typeface="Aptos"/>
+              </a:defRPr>
+            </a:pPr>
+            <a:r>
+              <a:t>Isolated local development port mapping host 8085 -&gt; container 80 for seamless local multi-tier testing.</a:t>
+            </a:r>
+          </a:p>
+        </p:txBody>
+      </p:sp>
+      <p:sp>
+        <p:nvSpPr>
+          <p:cNvPr id="13" name="Rounded Rectangle 12"/>
+          <p:cNvSpPr/>
+          <p:nvPr/>
+        </p:nvSpPr>
+        <p:spPr>
+          <a:xfrm>
+            <a:off x="640080" y="3566160"/>
+            <a:ext cx="3429000" cy="1874519"/>
+          </a:xfrm>
+          <a:prstGeom prst="roundRect">
+            <a:avLst/>
+          </a:prstGeom>
+          <a:solidFill>
+            <a:srgbClr val="26114C"/>
+          </a:solidFill>
+          <a:ln w="19050">
+            <a:solidFill>
+              <a:srgbClr val="4E97EB"/>
+            </a:solidFill>
+          </a:ln>
+        </p:spPr>
+        <p:style>
+          <a:lnRef idx="1">
+            <a:schemeClr val="accent1"/>
+          </a:lnRef>
+          <a:fillRef idx="3">
+            <a:schemeClr val="accent1"/>
+          </a:fillRef>
+          <a:effectRef idx="2">
+            <a:schemeClr val="accent1"/>
+          </a:effectRef>
+          <a:fontRef idx="minor">
+            <a:schemeClr val="lt1"/>
+          </a:fontRef>
+        </p:style>
+        <p:txBody>
+          <a:bodyPr rtlCol="0" anchor="ctr"/>
+          <a:lstStyle/>
+          <a:p>
+            <a:pPr algn="ctr"/>
+          </a:p>
+        </p:txBody>
+      </p:sp>
+      <p:sp>
+        <p:nvSpPr>
+          <p:cNvPr id="14" name="TextBox 13"/>
+          <p:cNvSpPr txBox="1"/>
+          <p:nvPr/>
+        </p:nvSpPr>
+        <p:spPr>
+          <a:xfrm>
+            <a:off x="804671" y="3685032"/>
+            <a:ext cx="3108960" cy="347472"/>
+          </a:xfrm>
+          <a:prstGeom prst="rect">
+            <a:avLst/>
+          </a:prstGeom>
+          <a:noFill/>
+        </p:spPr>
+        <p:txBody>
+          <a:bodyPr wrap="square">
+            <a:spAutoFit/>
+          </a:bodyPr>
+          <a:lstStyle/>
+          <a:p>
+            <a:pPr>
+              <a:defRPr sz="1400" b="1">
+                <a:solidFill>
+                  <a:srgbClr val="FFFFFF"/>
+                </a:solidFill>
+                <a:latin typeface="Aptos"/>
+              </a:defRPr>
+            </a:pPr>
+            <a:r>
+              <a:t>Port 3306 (MySQL Database)</a:t>
+            </a:r>
+          </a:p>
+        </p:txBody>
+      </p:sp>
+      <p:sp>
+        <p:nvSpPr>
+          <p:cNvPr id="15" name="TextBox 14"/>
+          <p:cNvSpPr txBox="1"/>
+          <p:nvPr/>
+        </p:nvSpPr>
+        <p:spPr>
+          <a:xfrm>
+            <a:off x="804671" y="4069080"/>
+            <a:ext cx="3108960" cy="1252727"/>
+          </a:xfrm>
+          <a:prstGeom prst="rect">
+            <a:avLst/>
+          </a:prstGeom>
+          <a:noFill/>
+        </p:spPr>
+        <p:txBody>
+          <a:bodyPr wrap="square">
+            <a:spAutoFit/>
+          </a:bodyPr>
+          <a:lstStyle/>
+          <a:p>
+            <a:pPr>
+              <a:defRPr sz="1000">
+                <a:solidFill>
+                  <a:srgbClr val="EBE5FA"/>
+                </a:solidFill>
+                <a:latin typeface="Aptos"/>
+              </a:defRPr>
+            </a:pPr>
+            <a:r>
+              <a:t>Bound strictly to internal cluster network (mysql-service:3306); completely blocked from external public access.</a:t>
+            </a:r>
+          </a:p>
+        </p:txBody>
+      </p:sp>
+      <p:sp>
+        <p:nvSpPr>
+          <p:cNvPr id="16" name="Rounded Rectangle 15"/>
+          <p:cNvSpPr/>
+          <p:nvPr/>
+        </p:nvSpPr>
+        <p:spPr>
+          <a:xfrm>
+            <a:off x="4389120" y="3566160"/>
+            <a:ext cx="3429000" cy="1874519"/>
+          </a:xfrm>
+          <a:prstGeom prst="roundRect">
+            <a:avLst/>
+          </a:prstGeom>
+          <a:solidFill>
+            <a:srgbClr val="26114C"/>
+          </a:solidFill>
+          <a:ln w="19050">
+            <a:solidFill>
+              <a:srgbClr val="4E97EB"/>
+            </a:solidFill>
+          </a:ln>
+        </p:spPr>
+        <p:style>
+          <a:lnRef idx="1">
+            <a:schemeClr val="accent1"/>
+          </a:lnRef>
+          <a:fillRef idx="3">
+            <a:schemeClr val="accent1"/>
+          </a:fillRef>
+          <a:effectRef idx="2">
+            <a:schemeClr val="accent1"/>
+          </a:effectRef>
+          <a:fontRef idx="minor">
+            <a:schemeClr val="lt1"/>
+          </a:fontRef>
+        </p:style>
+        <p:txBody>
+          <a:bodyPr rtlCol="0" anchor="ctr"/>
+          <a:lstStyle/>
+          <a:p>
+            <a:pPr algn="ctr"/>
+          </a:p>
+        </p:txBody>
+      </p:sp>
+      <p:sp>
+        <p:nvSpPr>
+          <p:cNvPr id="17" name="TextBox 16"/>
+          <p:cNvSpPr txBox="1"/>
+          <p:nvPr/>
+        </p:nvSpPr>
+        <p:spPr>
+          <a:xfrm>
+            <a:off x="4553711" y="3685032"/>
+            <a:ext cx="3108960" cy="347472"/>
+          </a:xfrm>
+          <a:prstGeom prst="rect">
+            <a:avLst/>
+          </a:prstGeom>
+          <a:noFill/>
+        </p:spPr>
+        <p:txBody>
+          <a:bodyPr wrap="square">
+            <a:spAutoFit/>
+          </a:bodyPr>
+          <a:lstStyle/>
+          <a:p>
+            <a:pPr>
+              <a:defRPr sz="1400" b="1">
+                <a:solidFill>
+                  <a:srgbClr val="FFFFFF"/>
+                </a:solidFill>
+                <a:latin typeface="Aptos"/>
+              </a:defRPr>
+            </a:pPr>
+            <a:r>
+              <a:t>AWS Security Groups</a:t>
+            </a:r>
+          </a:p>
+        </p:txBody>
+      </p:sp>
+      <p:sp>
+        <p:nvSpPr>
+          <p:cNvPr id="18" name="TextBox 17"/>
+          <p:cNvSpPr txBox="1"/>
+          <p:nvPr/>
+        </p:nvSpPr>
+        <p:spPr>
+          <a:xfrm>
+            <a:off x="4553711" y="4069080"/>
+            <a:ext cx="3108960" cy="1252727"/>
+          </a:xfrm>
+          <a:prstGeom prst="rect">
+            <a:avLst/>
+          </a:prstGeom>
+          <a:noFill/>
+        </p:spPr>
+        <p:txBody>
+          <a:bodyPr wrap="square">
+            <a:spAutoFit/>
+          </a:bodyPr>
+          <a:lstStyle/>
+          <a:p>
+            <a:pPr>
+              <a:defRPr sz="1000">
+                <a:solidFill>
+                  <a:srgbClr val="EBE5FA"/>
+                </a:solidFill>
+                <a:latin typeface="Aptos"/>
+              </a:defRPr>
+            </a:pPr>
+            <a:r>
+              <a:t>SG-EKS permits HTTP/HTTPS inbound from internet; SG-RDS restricts MySQL ingress strictly to SG-EKS nodes.</a:t>
+            </a:r>
+          </a:p>
+        </p:txBody>
+      </p:sp>
+      <p:sp>
+        <p:nvSpPr>
+          <p:cNvPr id="19" name="Rounded Rectangle 18"/>
+          <p:cNvSpPr/>
+          <p:nvPr/>
+        </p:nvSpPr>
+        <p:spPr>
+          <a:xfrm>
+            <a:off x="8138160" y="3566160"/>
+            <a:ext cx="3429000" cy="1874519"/>
+          </a:xfrm>
+          <a:prstGeom prst="roundRect">
+            <a:avLst/>
+          </a:prstGeom>
+          <a:solidFill>
+            <a:srgbClr val="26114C"/>
+          </a:solidFill>
+          <a:ln w="19050">
+            <a:solidFill>
+              <a:srgbClr val="4E97EB"/>
+            </a:solidFill>
+          </a:ln>
+        </p:spPr>
+        <p:style>
+          <a:lnRef idx="1">
+            <a:schemeClr val="accent1"/>
+          </a:lnRef>
+          <a:fillRef idx="3">
+            <a:schemeClr val="accent1"/>
+          </a:fillRef>
+          <a:effectRef idx="2">
+            <a:schemeClr val="accent1"/>
+          </a:effectRef>
+          <a:fontRef idx="minor">
+            <a:schemeClr val="lt1"/>
+          </a:fontRef>
+        </p:style>
+        <p:txBody>
+          <a:bodyPr rtlCol="0" anchor="ctr"/>
+          <a:lstStyle/>
+          <a:p>
+            <a:pPr algn="ctr"/>
+          </a:p>
+        </p:txBody>
+      </p:sp>
+      <p:sp>
+        <p:nvSpPr>
+          <p:cNvPr id="20" name="TextBox 19"/>
+          <p:cNvSpPr txBox="1"/>
+          <p:nvPr/>
+        </p:nvSpPr>
+        <p:spPr>
+          <a:xfrm>
+            <a:off x="8302751" y="3685032"/>
+            <a:ext cx="3108960" cy="347472"/>
+          </a:xfrm>
+          <a:prstGeom prst="rect">
+            <a:avLst/>
+          </a:prstGeom>
+          <a:noFill/>
+        </p:spPr>
+        <p:txBody>
+          <a:bodyPr wrap="square">
+            <a:spAutoFit/>
+          </a:bodyPr>
+          <a:lstStyle/>
+          <a:p>
+            <a:pPr>
+              <a:defRPr sz="1400" b="1">
+                <a:solidFill>
+                  <a:srgbClr val="FFFFFF"/>
+                </a:solidFill>
+                <a:latin typeface="Aptos"/>
+              </a:defRPr>
+            </a:pPr>
+            <a:r>
+              <a:t>Health Probe Endpoint</a:t>
+            </a:r>
+          </a:p>
+        </p:txBody>
+      </p:sp>
+      <p:sp>
+        <p:nvSpPr>
+          <p:cNvPr id="21" name="TextBox 20"/>
+          <p:cNvSpPr txBox="1"/>
+          <p:nvPr/>
+        </p:nvSpPr>
+        <p:spPr>
+          <a:xfrm>
+            <a:off x="8302751" y="4069080"/>
+            <a:ext cx="3108960" cy="1252727"/>
+          </a:xfrm>
+          <a:prstGeom prst="rect">
+            <a:avLst/>
+          </a:prstGeom>
+          <a:noFill/>
+        </p:spPr>
+        <p:txBody>
+          <a:bodyPr wrap="square">
+            <a:spAutoFit/>
+          </a:bodyPr>
+          <a:lstStyle/>
+          <a:p>
+            <a:pPr>
+              <a:defRPr sz="1000">
+                <a:solidFill>
+                  <a:srgbClr val="EBE5FA"/>
+                </a:solidFill>
+                <a:latin typeface="Aptos"/>
+              </a:defRPr>
+            </a:pPr>
+            <a:r>
+              <a:t>Dedicated /health.php endpoint returning JSON status for automated Kubernetes liveness/readiness self-healing.</a:t>
+            </a:r>
+          </a:p>
+        </p:txBody>
+      </p:sp>
+      <p:sp>
+        <p:nvSpPr>
+          <p:cNvPr id="22" name="TextBox 21"/>
+          <p:cNvSpPr txBox="1"/>
+          <p:nvPr/>
+        </p:nvSpPr>
+        <p:spPr>
+          <a:xfrm>
+            <a:off x="594360" y="6565392"/>
+            <a:ext cx="10972800" cy="182880"/>
+          </a:xfrm>
+          <a:prstGeom prst="rect">
+            <a:avLst/>
+          </a:prstGeom>
+          <a:noFill/>
+        </p:spPr>
+        <p:txBody>
+          <a:bodyPr wrap="none">
+            <a:spAutoFit/>
+          </a:bodyPr>
+          <a:lstStyle/>
+          <a:p>
+            <a:pPr>
+              <a:defRPr sz="900">
+                <a:solidFill>
+                  <a:srgbClr val="BEB2DC"/>
+                </a:solidFill>
+                <a:latin typeface="Aptos"/>
+              </a:defRPr>
+            </a:pPr>
+            <a:r>
+              <a:t>VoteSecure • Network &amp; Security • 24</a:t>
+            </a:r>
+          </a:p>
+        </p:txBody>
+      </p:sp>
+    </p:spTree>
   </p:cSld>
   <p:clrMapOvr>
     <a:masterClrMapping/>

</xml_diff>